<commit_message>
docs: refine subject titles and remove editing commentary
</commit_message>
<xml_diff>
--- a/deliverables/2026_한이음_제작설계서_프론트엔드_핵심정리본.pptx
+++ b/deliverables/2026_한이음_제작설계서_프론트엔드_핵심정리본.pptx
@@ -2,26 +2,26 @@
 <file path=ppt/presentation.xml><?xml version="1.0" encoding="utf-8"?>
 <p:presentation xmlns:p="http://schemas.openxmlformats.org/presentationml/2006/main">
   <p:sldMasterIdLst>
-    <p:sldMasterId xmlns:r="http://schemas.openxmlformats.org/officeDocument/2006/relationships" id="2147483648" r:id="R47cce09a3cbb4e06"/>
+    <p:sldMasterId xmlns:r="http://schemas.openxmlformats.org/officeDocument/2006/relationships" id="2147483648" r:id="R1094e7c55d3749ac"/>
   </p:sldMasterIdLst>
   <p:notesMasterIdLst>
-    <p:notesMasterId xmlns:r="http://schemas.openxmlformats.org/officeDocument/2006/relationships" r:id="R8d8720ea29624d19"/>
+    <p:notesMasterId xmlns:r="http://schemas.openxmlformats.org/officeDocument/2006/relationships" r:id="Rd9dda73bd93e470d"/>
   </p:notesMasterIdLst>
   <p:sldIdLst>
-    <p:sldId xmlns:r="http://schemas.openxmlformats.org/officeDocument/2006/relationships" id="256" r:id="R56366d841b744d58"/>
-    <p:sldId xmlns:r="http://schemas.openxmlformats.org/officeDocument/2006/relationships" id="257" r:id="R23bcfe3493754727"/>
-    <p:sldId xmlns:r="http://schemas.openxmlformats.org/officeDocument/2006/relationships" id="258" r:id="Rfdfbcb3bf4824c37"/>
-    <p:sldId xmlns:r="http://schemas.openxmlformats.org/officeDocument/2006/relationships" id="259" r:id="R53fd57abf0284d6f"/>
-    <p:sldId xmlns:r="http://schemas.openxmlformats.org/officeDocument/2006/relationships" id="260" r:id="R28744e2b28d14db7"/>
-    <p:sldId xmlns:r="http://schemas.openxmlformats.org/officeDocument/2006/relationships" id="261" r:id="R28379623534d46e8"/>
-    <p:sldId xmlns:r="http://schemas.openxmlformats.org/officeDocument/2006/relationships" id="262" r:id="R391f8f550ce0431f"/>
-    <p:sldId xmlns:r="http://schemas.openxmlformats.org/officeDocument/2006/relationships" id="263" r:id="Ra4ef9a2982b24831"/>
-    <p:sldId xmlns:r="http://schemas.openxmlformats.org/officeDocument/2006/relationships" id="264" r:id="Rb29f999a12bc48e7"/>
-    <p:sldId xmlns:r="http://schemas.openxmlformats.org/officeDocument/2006/relationships" id="265" r:id="R13544cc711d74d41"/>
-    <p:sldId xmlns:r="http://schemas.openxmlformats.org/officeDocument/2006/relationships" id="266" r:id="R50ea62d422e94375"/>
-    <p:sldId xmlns:r="http://schemas.openxmlformats.org/officeDocument/2006/relationships" id="267" r:id="R235467428b584506"/>
-    <p:sldId xmlns:r="http://schemas.openxmlformats.org/officeDocument/2006/relationships" id="268" r:id="Rb22cb255cb73484f"/>
-    <p:sldId xmlns:r="http://schemas.openxmlformats.org/officeDocument/2006/relationships" id="269" r:id="R575b96ba1b39471a"/>
+    <p:sldId xmlns:r="http://schemas.openxmlformats.org/officeDocument/2006/relationships" id="256" r:id="R32387a80d3404341"/>
+    <p:sldId xmlns:r="http://schemas.openxmlformats.org/officeDocument/2006/relationships" id="257" r:id="R7b6a2413c87248f8"/>
+    <p:sldId xmlns:r="http://schemas.openxmlformats.org/officeDocument/2006/relationships" id="258" r:id="R00dadbbb5b8a48e6"/>
+    <p:sldId xmlns:r="http://schemas.openxmlformats.org/officeDocument/2006/relationships" id="259" r:id="Re183ba13c73346e3"/>
+    <p:sldId xmlns:r="http://schemas.openxmlformats.org/officeDocument/2006/relationships" id="260" r:id="Rb3dcd7a6ae524e37"/>
+    <p:sldId xmlns:r="http://schemas.openxmlformats.org/officeDocument/2006/relationships" id="261" r:id="Rbd5c7f8d3ffe4970"/>
+    <p:sldId xmlns:r="http://schemas.openxmlformats.org/officeDocument/2006/relationships" id="262" r:id="R492c53d2229e4f8a"/>
+    <p:sldId xmlns:r="http://schemas.openxmlformats.org/officeDocument/2006/relationships" id="263" r:id="Red5a3423d8ec469b"/>
+    <p:sldId xmlns:r="http://schemas.openxmlformats.org/officeDocument/2006/relationships" id="264" r:id="Rcc9a8b04be054a55"/>
+    <p:sldId xmlns:r="http://schemas.openxmlformats.org/officeDocument/2006/relationships" id="265" r:id="Rd8e41b7a01ae4074"/>
+    <p:sldId xmlns:r="http://schemas.openxmlformats.org/officeDocument/2006/relationships" id="266" r:id="Rb2737f3752d949e6"/>
+    <p:sldId xmlns:r="http://schemas.openxmlformats.org/officeDocument/2006/relationships" id="267" r:id="Rf49b62cd17df485f"/>
+    <p:sldId xmlns:r="http://schemas.openxmlformats.org/officeDocument/2006/relationships" id="268" r:id="R32273a5c4ec14de1"/>
+    <p:sldId xmlns:r="http://schemas.openxmlformats.org/officeDocument/2006/relationships" id="269" r:id="R72da2d0d88b34a06"/>
   </p:sldIdLst>
   <p:sldSz cx="9144000" cy="6858000"/>
   <p:notesSz cx="6858000" cy="9144000"/>
@@ -493,7 +493,7 @@
           </a:p>
           <a:p xmlns:a="http://schemas.openxmlformats.org/drawingml/2006/main">
             <a:r>
-              <a:t>원본 제작설계서 양식을 유지한 프론트엔드 핵심 정리본. 백엔드와 데이터베이스 상세 설계는 편집 범위에 포함하지 않는다.</a:t>
+              <a:t>범위: 프론트엔드의 화면과 사용자 동작, 입력과 실행 기록 처리.</a:t>
             </a:r>
           </a:p>
           <a:p xmlns:a="http://schemas.openxmlformats.org/drawingml/2006/main">
@@ -503,7 +503,7 @@
           </a:p>
           <a:p xmlns:a="http://schemas.openxmlformats.org/drawingml/2006/main">
             <a:r>
-              <a:t>기존 37장 프론트엔드 제작설계서를 14장으로 재구성했다. 사용자 제공 중간보고서의 S/W 주요 기능처럼 사용자 입력, 처리, 결과를 기능별로 묶었다. 원본 양식, 글꼴과 실제 화면은 유지했다.</a:t>
+              <a:t>화면의 일정과 수치는 시연용 예시이며 실제 사용자 개인정보를 포함하지 않는다.</a:t>
             </a:r>
           </a:p>
         </p:txBody>
@@ -578,7 +578,7 @@
           </a:p>
           <a:p xmlns:a="http://schemas.openxmlformats.org/drawingml/2006/main">
             <a:r>
-              <a:t>원본 제작설계서 양식을 유지한 프론트엔드 핵심 정리본. 백엔드와 데이터베이스 상세 설계는 편집 범위에 포함하지 않는다.</a:t>
+              <a:t>범위: 프론트엔드의 화면과 사용자 동작, 입력과 실행 기록 처리.</a:t>
             </a:r>
           </a:p>
           <a:p xmlns:a="http://schemas.openxmlformats.org/drawingml/2006/main">
@@ -678,7 +678,7 @@
           </a:p>
           <a:p xmlns:a="http://schemas.openxmlformats.org/drawingml/2006/main">
             <a:r>
-              <a:t>원본 제작설계서 양식을 유지한 프론트엔드 핵심 정리본. 백엔드와 데이터베이스 상세 설계는 편집 범위에 포함하지 않는다.</a:t>
+              <a:t>범위: 프론트엔드의 화면과 사용자 동작, 입력과 실행 기록 처리.</a:t>
             </a:r>
           </a:p>
           <a:p xmlns:a="http://schemas.openxmlformats.org/drawingml/2006/main">
@@ -768,7 +768,7 @@
           </a:p>
           <a:p xmlns:a="http://schemas.openxmlformats.org/drawingml/2006/main">
             <a:r>
-              <a:t>원본 제작설계서 양식을 유지한 프론트엔드 핵심 정리본. 백엔드와 데이터베이스 상세 설계는 편집 범위에 포함하지 않는다.</a:t>
+              <a:t>범위: 프론트엔드의 화면과 사용자 동작, 입력과 실행 기록 처리.</a:t>
             </a:r>
           </a:p>
           <a:p xmlns:a="http://schemas.openxmlformats.org/drawingml/2006/main">
@@ -853,7 +853,7 @@
           </a:p>
           <a:p xmlns:a="http://schemas.openxmlformats.org/drawingml/2006/main">
             <a:r>
-              <a:t>원본 제작설계서 양식을 유지한 프론트엔드 핵심 정리본. 백엔드와 데이터베이스 상세 설계는 편집 범위에 포함하지 않는다.</a:t>
+              <a:t>범위: 프론트엔드의 화면과 사용자 동작, 입력과 실행 기록 처리.</a:t>
             </a:r>
           </a:p>
           <a:p xmlns:a="http://schemas.openxmlformats.org/drawingml/2006/main">
@@ -953,7 +953,7 @@
           </a:p>
           <a:p xmlns:a="http://schemas.openxmlformats.org/drawingml/2006/main">
             <a:r>
-              <a:t>원본 제작설계서 양식을 유지한 프론트엔드 핵심 정리본. 백엔드와 데이터베이스 상세 설계는 편집 범위에 포함하지 않는다.</a:t>
+              <a:t>범위: 프론트엔드의 화면과 사용자 동작, 입력과 실행 기록 처리.</a:t>
             </a:r>
           </a:p>
           <a:p xmlns:a="http://schemas.openxmlformats.org/drawingml/2006/main">
@@ -978,7 +978,7 @@
           </a:p>
           <a:p xmlns:a="http://schemas.openxmlformats.org/drawingml/2006/main">
             <a:r>
-              <a:t>기준일 2026-09-05. 완료율이나 임의 완성 기한을 붙이지 않고 남은 사용자 동작을 명시한다.</a:t>
+              <a:t>기준일 2026-09-05의 미완료 작업.</a:t>
             </a:r>
           </a:p>
           <a:p xmlns:a="http://schemas.openxmlformats.org/drawingml/2006/main">
@@ -1003,7 +1003,7 @@
           </a:p>
           <a:p xmlns:a="http://schemas.openxmlformats.org/drawingml/2006/main">
             <a:r>
-              <a:t>현재 UI는 크림 배경 #FAF6EE, 카드 #FFFCF6, 주요 동작 #E26D4E/#9E472F, 완료 #5D9767/#487550과 Pretendard Variable을 사용한다. 앱 색상은 실제 캡처에 유지하고, 문서 양식과 글꼴은 기존 제작설계서 것을 유지했다.</a:t>
+              <a:t>현재 UI는 크림 배경 #FAF6EE, 카드 #FFFCF6, 주요 동작 #E26D4E/#9E472F, 완료 #5D9767/#487550과 Pretendard Variable을 사용한다.</a:t>
             </a:r>
           </a:p>
         </p:txBody>
@@ -1078,7 +1078,7 @@
           </a:p>
           <a:p xmlns:a="http://schemas.openxmlformats.org/drawingml/2006/main">
             <a:r>
-              <a:t>원본 제작설계서 양식을 유지한 프론트엔드 핵심 정리본. 백엔드와 데이터베이스 상세 설계는 편집 범위에 포함하지 않는다.</a:t>
+              <a:t>범위: 프론트엔드의 화면과 사용자 동작, 입력과 실행 기록 처리.</a:t>
             </a:r>
           </a:p>
           <a:p xmlns:a="http://schemas.openxmlformats.org/drawingml/2006/main">
@@ -1173,7 +1173,7 @@
           </a:p>
           <a:p xmlns:a="http://schemas.openxmlformats.org/drawingml/2006/main">
             <a:r>
-              <a:t>원본 제작설계서 양식을 유지한 프론트엔드 핵심 정리본. 백엔드와 데이터베이스 상세 설계는 편집 범위에 포함하지 않는다.</a:t>
+              <a:t>범위: 프론트엔드의 화면과 사용자 동작, 입력과 실행 기록 처리.</a:t>
             </a:r>
           </a:p>
           <a:p xmlns:a="http://schemas.openxmlformats.org/drawingml/2006/main">
@@ -1183,7 +1183,7 @@
           </a:p>
           <a:p xmlns:a="http://schemas.openxmlformats.org/drawingml/2006/main">
             <a:r>
-              <a:t>연결선은 사용자와 사용 목적의 관계이며 실행 순서가 아니다. 로그인, 설정과 프로필은 공통 보조 기능으로 별도 화면 나열을 생략했다. UC-03의 회복은 일부 완료 또는 실패 시에만 이어진다.</a:t>
+              <a:t>연결선은 사용자와 사용 목적의 관계이며 실행 순서가 아니다. 로그인, 설정과 프로필은 공통 보조 기능이다. UC-03의 회복은 일부 완료 또는 실패 시에만 이어진다.</a:t>
             </a:r>
           </a:p>
         </p:txBody>
@@ -1258,7 +1258,7 @@
           </a:p>
           <a:p xmlns:a="http://schemas.openxmlformats.org/drawingml/2006/main">
             <a:r>
-              <a:t>원본 제작설계서 양식을 유지한 프론트엔드 핵심 정리본. 백엔드와 데이터베이스 상세 설계는 편집 범위에 포함하지 않는다.</a:t>
+              <a:t>범위: 프론트엔드의 화면과 사용자 동작, 입력과 실행 기록 처리.</a:t>
             </a:r>
           </a:p>
           <a:p xmlns:a="http://schemas.openxmlformats.org/drawingml/2006/main">
@@ -1353,7 +1353,7 @@
           </a:p>
           <a:p xmlns:a="http://schemas.openxmlformats.org/drawingml/2006/main">
             <a:r>
-              <a:t>원본 제작설계서 양식을 유지한 프론트엔드 핵심 정리본. 백엔드와 데이터베이스 상세 설계는 편집 범위에 포함하지 않는다.</a:t>
+              <a:t>범위: 프론트엔드의 화면과 사용자 동작, 입력과 실행 기록 처리.</a:t>
             </a:r>
           </a:p>
           <a:p xmlns:a="http://schemas.openxmlformats.org/drawingml/2006/main">
@@ -1443,7 +1443,7 @@
           </a:p>
           <a:p xmlns:a="http://schemas.openxmlformats.org/drawingml/2006/main">
             <a:r>
-              <a:t>원본 제작설계서 양식을 유지한 프론트엔드 핵심 정리본. 백엔드와 데이터베이스 상세 설계는 편집 범위에 포함하지 않는다.</a:t>
+              <a:t>범위: 프론트엔드의 화면과 사용자 동작, 입력과 실행 기록 처리.</a:t>
             </a:r>
           </a:p>
           <a:p xmlns:a="http://schemas.openxmlformats.org/drawingml/2006/main">
@@ -1533,7 +1533,7 @@
           </a:p>
           <a:p xmlns:a="http://schemas.openxmlformats.org/drawingml/2006/main">
             <a:r>
-              <a:t>원본 제작설계서 양식을 유지한 프론트엔드 핵심 정리본. 백엔드와 데이터베이스 상세 설계는 편집 범위에 포함하지 않는다.</a:t>
+              <a:t>범위: 프론트엔드의 화면과 사용자 동작, 입력과 실행 기록 처리.</a:t>
             </a:r>
           </a:p>
           <a:p xmlns:a="http://schemas.openxmlformats.org/drawingml/2006/main">
@@ -1628,7 +1628,7 @@
           </a:p>
           <a:p xmlns:a="http://schemas.openxmlformats.org/drawingml/2006/main">
             <a:r>
-              <a:t>원본 제작설계서 양식을 유지한 프론트엔드 핵심 정리본. 백엔드와 데이터베이스 상세 설계는 편집 범위에 포함하지 않는다.</a:t>
+              <a:t>범위: 프론트엔드의 화면과 사용자 동작, 입력과 실행 기록 처리.</a:t>
             </a:r>
           </a:p>
           <a:p xmlns:a="http://schemas.openxmlformats.org/drawingml/2006/main">
@@ -1723,7 +1723,7 @@
           </a:p>
           <a:p xmlns:a="http://schemas.openxmlformats.org/drawingml/2006/main">
             <a:r>
-              <a:t>원본 제작설계서 양식을 유지한 프론트엔드 핵심 정리본. 백엔드와 데이터베이스 상세 설계는 편집 범위에 포함하지 않는다.</a:t>
+              <a:t>범위: 프론트엔드의 화면과 사용자 동작, 입력과 실행 기록 처리.</a:t>
             </a:r>
           </a:p>
           <a:p xmlns:a="http://schemas.openxmlformats.org/drawingml/2006/main">
@@ -4778,17 +4778,17 @@
   </p:cSld>
   <p:clrMap bg1="lt1" tx1="dk1" bg2="lt2" tx2="dk2" accent1="accent1" accent2="accent2" accent3="accent3" accent4="accent4" accent5="accent5" accent6="accent6" hlink="hlink" folHlink="folHlink"/>
   <p:sldLayoutIdLst>
-    <p:sldLayoutId xmlns:r="http://schemas.openxmlformats.org/officeDocument/2006/relationships" id="2147483649" r:id="R52ca68e2ec4f4e9b"/>
-    <p:sldLayoutId xmlns:r="http://schemas.openxmlformats.org/officeDocument/2006/relationships" id="2147483650" r:id="R6cb8ae6de3a54430"/>
-    <p:sldLayoutId xmlns:r="http://schemas.openxmlformats.org/officeDocument/2006/relationships" id="2147483651" r:id="Rf23c566381164aa0"/>
-    <p:sldLayoutId xmlns:r="http://schemas.openxmlformats.org/officeDocument/2006/relationships" id="2147483652" r:id="R00c8e8939fba4682"/>
-    <p:sldLayoutId xmlns:r="http://schemas.openxmlformats.org/officeDocument/2006/relationships" id="2147483653" r:id="R6f2ea4c0a576439d"/>
-    <p:sldLayoutId xmlns:r="http://schemas.openxmlformats.org/officeDocument/2006/relationships" id="2147483654" r:id="Rbee9c4057a294a53"/>
-    <p:sldLayoutId xmlns:r="http://schemas.openxmlformats.org/officeDocument/2006/relationships" id="2147483655" r:id="Rbc8bffb12ff441df"/>
-    <p:sldLayoutId xmlns:r="http://schemas.openxmlformats.org/officeDocument/2006/relationships" id="2147483656" r:id="Rc01fab1cb2b54273"/>
-    <p:sldLayoutId xmlns:r="http://schemas.openxmlformats.org/officeDocument/2006/relationships" id="2147483657" r:id="Rcbca5430599d4928"/>
-    <p:sldLayoutId xmlns:r="http://schemas.openxmlformats.org/officeDocument/2006/relationships" id="2147483658" r:id="Rb89c6468365a42e7"/>
-    <p:sldLayoutId xmlns:r="http://schemas.openxmlformats.org/officeDocument/2006/relationships" id="2147483659" r:id="Ra576b5a81aa14dcf"/>
+    <p:sldLayoutId xmlns:r="http://schemas.openxmlformats.org/officeDocument/2006/relationships" id="2147483649" r:id="R696dd979e7ba46ee"/>
+    <p:sldLayoutId xmlns:r="http://schemas.openxmlformats.org/officeDocument/2006/relationships" id="2147483650" r:id="R3957ff3392184e15"/>
+    <p:sldLayoutId xmlns:r="http://schemas.openxmlformats.org/officeDocument/2006/relationships" id="2147483651" r:id="R65dd130601684da1"/>
+    <p:sldLayoutId xmlns:r="http://schemas.openxmlformats.org/officeDocument/2006/relationships" id="2147483652" r:id="R94fd42ce0d26495e"/>
+    <p:sldLayoutId xmlns:r="http://schemas.openxmlformats.org/officeDocument/2006/relationships" id="2147483653" r:id="Rc8c1fc3e43894cdd"/>
+    <p:sldLayoutId xmlns:r="http://schemas.openxmlformats.org/officeDocument/2006/relationships" id="2147483654" r:id="Radfcd3a8b32b448d"/>
+    <p:sldLayoutId xmlns:r="http://schemas.openxmlformats.org/officeDocument/2006/relationships" id="2147483655" r:id="Rc305c51fbf6a4250"/>
+    <p:sldLayoutId xmlns:r="http://schemas.openxmlformats.org/officeDocument/2006/relationships" id="2147483656" r:id="Rad176233ee8c44ff"/>
+    <p:sldLayoutId xmlns:r="http://schemas.openxmlformats.org/officeDocument/2006/relationships" id="2147483657" r:id="R03e1112c5f034741"/>
+    <p:sldLayoutId xmlns:r="http://schemas.openxmlformats.org/officeDocument/2006/relationships" id="2147483658" r:id="Rd5161b7a335c4ca9"/>
+    <p:sldLayoutId xmlns:r="http://schemas.openxmlformats.org/officeDocument/2006/relationships" id="2147483659" r:id="R35b4d502fc7d490f"/>
   </p:sldLayoutIdLst>
   <p:hf sldNum="0" hdr="0" dt="0"/>
   <p:txStyles>
@@ -5399,7 +5399,7 @@
           <p:nvPr/>
         </p:nvPicPr>
         <p:blipFill rotWithShape="1">
-          <a:blip xmlns:r="http://schemas.openxmlformats.org/officeDocument/2006/relationships" xmlns:a="http://schemas.openxmlformats.org/drawingml/2006/main" r:embed="Ra7258fbf0bd444a0"/>
+          <a:blip xmlns:r="http://schemas.openxmlformats.org/officeDocument/2006/relationships" xmlns:a="http://schemas.openxmlformats.org/drawingml/2006/main" r:embed="R6d5865b174474825"/>
           <a:srcRect xmlns:a="http://schemas.openxmlformats.org/drawingml/2006/main" l="1036" t="0" r="0" b="0"/>
           <a:stretch xmlns:a="http://schemas.openxmlformats.org/drawingml/2006/main"/>
         </p:blipFill>
@@ -5425,7 +5425,7 @@
           <p:nvPr/>
         </p:nvPicPr>
         <p:blipFill>
-          <a:blip xmlns:r="http://schemas.openxmlformats.org/officeDocument/2006/relationships" xmlns:a="http://schemas.openxmlformats.org/drawingml/2006/main" r:embed="R1b489f8e0fa2400d"/>
+          <a:blip xmlns:r="http://schemas.openxmlformats.org/officeDocument/2006/relationships" xmlns:a="http://schemas.openxmlformats.org/drawingml/2006/main" r:embed="R70b2df94db544ca9"/>
           <a:srcRect xmlns:a="http://schemas.openxmlformats.org/drawingml/2006/main" l="21956" t="40516" r="21023" b="44641"/>
           <a:stretch xmlns:a="http://schemas.openxmlformats.org/drawingml/2006/main"/>
         </p:blipFill>
@@ -5444,7 +5444,7 @@
           <p:cNvPr id="34" name="">
             <a:extLst xmlns:a="http://schemas.openxmlformats.org/drawingml/2006/main">
               <a:ext uri="{FF2B5EF4-FFF2-40B4-BE49-F238E27FC236}">
-                <a16:creationId xmlns:a16="http://schemas.microsoft.com/office/drawing/2014/main" id="{064F9506-6842-4ED1-A34D-38C83BCC28AA}"/>
+                <a16:creationId xmlns:a16="http://schemas.microsoft.com/office/drawing/2014/main" id="{C838B818-4722-41D6-9999-FF5BF3727060}"/>
               </a:ext>
             </a:extLst>
           </p:cNvPr>
@@ -5501,7 +5501,7 @@
           <p:cNvPr id="35" name="">
             <a:extLst xmlns:a="http://schemas.openxmlformats.org/drawingml/2006/main">
               <a:ext uri="{FF2B5EF4-FFF2-40B4-BE49-F238E27FC236}">
-                <a16:creationId xmlns:a16="http://schemas.microsoft.com/office/drawing/2014/main" id="{564160F5-A085-4973-A789-725EAA06CC50}"/>
+                <a16:creationId xmlns:a16="http://schemas.microsoft.com/office/drawing/2014/main" id="{87AD1061-17E8-466C-B723-EFB59BE31F08}"/>
               </a:ext>
             </a:extLst>
           </p:cNvPr>
@@ -5558,7 +5558,7 @@
           <p:cNvPr id="36" name="">
             <a:extLst xmlns:a="http://schemas.openxmlformats.org/drawingml/2006/main">
               <a:ext uri="{FF2B5EF4-FFF2-40B4-BE49-F238E27FC236}">
-                <a16:creationId xmlns:a16="http://schemas.microsoft.com/office/drawing/2014/main" id="{656473FD-A78E-440B-B452-151A78681C45}"/>
+                <a16:creationId xmlns:a16="http://schemas.microsoft.com/office/drawing/2014/main" id="{20D12458-C72B-4807-9B2D-D568ACD8C4B5}"/>
               </a:ext>
             </a:extLst>
           </p:cNvPr>
@@ -5615,7 +5615,7 @@
           <p:cNvPr id="37" name="">
             <a:extLst xmlns:a="http://schemas.openxmlformats.org/drawingml/2006/main">
               <a:ext uri="{FF2B5EF4-FFF2-40B4-BE49-F238E27FC236}">
-                <a16:creationId xmlns:a16="http://schemas.microsoft.com/office/drawing/2014/main" id="{8426E704-2760-4FAA-95FA-6D0E2DC938CE}"/>
+                <a16:creationId xmlns:a16="http://schemas.microsoft.com/office/drawing/2014/main" id="{03F00555-8D46-42A9-8560-52F269D8442D}"/>
               </a:ext>
             </a:extLst>
           </p:cNvPr>
@@ -5922,7 +5922,7 @@
           <p:nvPr/>
         </p:nvPicPr>
         <p:blipFill>
-          <a:blip xmlns:r="http://schemas.openxmlformats.org/officeDocument/2006/relationships" xmlns:a="http://schemas.openxmlformats.org/drawingml/2006/main" r:embed="R8f753ac72452476b"/>
+          <a:blip xmlns:r="http://schemas.openxmlformats.org/officeDocument/2006/relationships" xmlns:a="http://schemas.openxmlformats.org/drawingml/2006/main" r:embed="R5ee3044b0d0944db"/>
           <a:srcRect xmlns:a="http://schemas.openxmlformats.org/drawingml/2006/main" l="0" t="0" r="0" b="0"/>
           <a:stretch xmlns:a="http://schemas.openxmlformats.org/drawingml/2006/main">
             <a:fillRect l="0" t="0" r="0" b="0"/>
@@ -6013,7 +6013,7 @@
           <p:cNvPr id="87" name="">
             <a:extLst xmlns:a="http://schemas.openxmlformats.org/drawingml/2006/main">
               <a:ext uri="{FF2B5EF4-FFF2-40B4-BE49-F238E27FC236}">
-                <a16:creationId xmlns:a16="http://schemas.microsoft.com/office/drawing/2014/main" id="{6098009F-3125-4D07-BAB0-B4A1CA07C61C}"/>
+                <a16:creationId xmlns:a16="http://schemas.microsoft.com/office/drawing/2014/main" id="{DD4A559E-A123-4AC4-A17C-3F5E99663702}"/>
               </a:ext>
             </a:extLst>
           </p:cNvPr>
@@ -6070,7 +6070,7 @@
           <p:cNvPr id="88" name="">
             <a:extLst xmlns:a="http://schemas.openxmlformats.org/drawingml/2006/main">
               <a:ext uri="{FF2B5EF4-FFF2-40B4-BE49-F238E27FC236}">
-                <a16:creationId xmlns:a16="http://schemas.microsoft.com/office/drawing/2014/main" id="{D2673DB2-B8C0-4537-9163-BC57377C8B79}"/>
+                <a16:creationId xmlns:a16="http://schemas.microsoft.com/office/drawing/2014/main" id="{CE89B624-4193-42E5-BB5E-35D81B793DEE}"/>
               </a:ext>
             </a:extLst>
           </p:cNvPr>
@@ -6127,7 +6127,7 @@
           <p:cNvPr id="89" name="">
             <a:extLst xmlns:a="http://schemas.openxmlformats.org/drawingml/2006/main">
               <a:ext uri="{FF2B5EF4-FFF2-40B4-BE49-F238E27FC236}">
-                <a16:creationId xmlns:a16="http://schemas.microsoft.com/office/drawing/2014/main" id="{4D26D761-4010-4E57-A69B-FA27DE4D3911}"/>
+                <a16:creationId xmlns:a16="http://schemas.microsoft.com/office/drawing/2014/main" id="{9056B695-78B3-4BFA-BEA1-AE11EEE20FF2}"/>
               </a:ext>
             </a:extLst>
           </p:cNvPr>
@@ -6188,7 +6188,7 @@
           <p:nvPr/>
         </p:nvPicPr>
         <p:blipFill>
-          <a:blip xmlns:r="http://schemas.openxmlformats.org/officeDocument/2006/relationships" xmlns:a="http://schemas.openxmlformats.org/drawingml/2006/main" r:embed="R34c32a577b0f4dbc"/>
+          <a:blip xmlns:r="http://schemas.openxmlformats.org/officeDocument/2006/relationships" xmlns:a="http://schemas.openxmlformats.org/drawingml/2006/main" r:embed="Rbb82ac84a9284a1b"/>
           <a:stretch xmlns:a="http://schemas.openxmlformats.org/drawingml/2006/main"/>
         </p:blipFill>
         <p:spPr>
@@ -6210,7 +6210,7 @@
           <p:nvPr/>
         </p:nvPicPr>
         <p:blipFill>
-          <a:blip xmlns:r="http://schemas.openxmlformats.org/officeDocument/2006/relationships" xmlns:a="http://schemas.openxmlformats.org/drawingml/2006/main" r:embed="R73ade6a8ae21426d"/>
+          <a:blip xmlns:r="http://schemas.openxmlformats.org/officeDocument/2006/relationships" xmlns:a="http://schemas.openxmlformats.org/drawingml/2006/main" r:embed="R347798df48144b46"/>
           <a:stretch xmlns:a="http://schemas.openxmlformats.org/drawingml/2006/main"/>
         </p:blipFill>
         <p:spPr>
@@ -6228,7 +6228,7 @@
           <p:cNvPr id="92" name="">
             <a:extLst xmlns:a="http://schemas.openxmlformats.org/drawingml/2006/main">
               <a:ext uri="{FF2B5EF4-FFF2-40B4-BE49-F238E27FC236}">
-                <a16:creationId xmlns:a16="http://schemas.microsoft.com/office/drawing/2014/main" id="{2FD0B02D-8B62-4AE4-94AB-3FD2975D25B6}"/>
+                <a16:creationId xmlns:a16="http://schemas.microsoft.com/office/drawing/2014/main" id="{B9B75DBD-E50B-404F-8F77-E4DF55AE4A01}"/>
               </a:ext>
             </a:extLst>
           </p:cNvPr>
@@ -6285,7 +6285,7 @@
           <p:cNvPr id="93" name="">
             <a:extLst xmlns:a="http://schemas.openxmlformats.org/drawingml/2006/main">
               <a:ext uri="{FF2B5EF4-FFF2-40B4-BE49-F238E27FC236}">
-                <a16:creationId xmlns:a16="http://schemas.microsoft.com/office/drawing/2014/main" id="{22224CDA-38E5-4854-AB3B-38AE8A5F2DDF}"/>
+                <a16:creationId xmlns:a16="http://schemas.microsoft.com/office/drawing/2014/main" id="{EBC73A2C-8E54-45A2-9D59-8568BE032BA3}"/>
               </a:ext>
             </a:extLst>
           </p:cNvPr>
@@ -6342,7 +6342,7 @@
           <p:cNvPr id="94" name="">
             <a:extLst xmlns:a="http://schemas.openxmlformats.org/drawingml/2006/main">
               <a:ext uri="{FF2B5EF4-FFF2-40B4-BE49-F238E27FC236}">
-                <a16:creationId xmlns:a16="http://schemas.microsoft.com/office/drawing/2014/main" id="{77A93C82-5DA9-40A8-AFAB-6BF5FB5DB336}"/>
+                <a16:creationId xmlns:a16="http://schemas.microsoft.com/office/drawing/2014/main" id="{67B01D29-7D91-429A-80D3-A41B7A56962F}"/>
               </a:ext>
             </a:extLst>
           </p:cNvPr>
@@ -6399,7 +6399,7 @@
           <p:cNvPr id="95" name="">
             <a:extLst xmlns:a="http://schemas.openxmlformats.org/drawingml/2006/main">
               <a:ext uri="{FF2B5EF4-FFF2-40B4-BE49-F238E27FC236}">
-                <a16:creationId xmlns:a16="http://schemas.microsoft.com/office/drawing/2014/main" id="{17EB77BE-CD20-4FB1-9825-90E8C67A086D}"/>
+                <a16:creationId xmlns:a16="http://schemas.microsoft.com/office/drawing/2014/main" id="{D83B8FDC-9071-4D56-AAB2-D8C5ABABBDF0}"/>
               </a:ext>
             </a:extLst>
           </p:cNvPr>
@@ -6525,7 +6525,7 @@
           <p:cNvPr id="96" name="">
             <a:extLst xmlns:a="http://schemas.openxmlformats.org/drawingml/2006/main">
               <a:ext uri="{FF2B5EF4-FFF2-40B4-BE49-F238E27FC236}">
-                <a16:creationId xmlns:a16="http://schemas.microsoft.com/office/drawing/2014/main" id="{B826D63D-6A4B-4E3D-A156-867777EF677A}"/>
+                <a16:creationId xmlns:a16="http://schemas.microsoft.com/office/drawing/2014/main" id="{2F6335A0-5F35-464B-9191-950C6DA48A62}"/>
               </a:ext>
             </a:extLst>
           </p:cNvPr>
@@ -6555,7 +6555,7 @@
           <p:cNvPr id="97" name="">
             <a:extLst xmlns:a="http://schemas.openxmlformats.org/drawingml/2006/main">
               <a:ext uri="{FF2B5EF4-FFF2-40B4-BE49-F238E27FC236}">
-                <a16:creationId xmlns:a16="http://schemas.microsoft.com/office/drawing/2014/main" id="{BC9DC0EB-06E8-4529-99A4-D54DC7D0893B}"/>
+                <a16:creationId xmlns:a16="http://schemas.microsoft.com/office/drawing/2014/main" id="{BBE5867D-8E80-40F0-8E79-F65FF72F1E85}"/>
               </a:ext>
             </a:extLst>
           </p:cNvPr>
@@ -6612,7 +6612,7 @@
           <p:cNvPr id="98" name="">
             <a:extLst xmlns:a="http://schemas.openxmlformats.org/drawingml/2006/main">
               <a:ext uri="{FF2B5EF4-FFF2-40B4-BE49-F238E27FC236}">
-                <a16:creationId xmlns:a16="http://schemas.microsoft.com/office/drawing/2014/main" id="{5C37A11E-1FCA-48BC-9A66-2A9F5D897D74}"/>
+                <a16:creationId xmlns:a16="http://schemas.microsoft.com/office/drawing/2014/main" id="{87F02B80-A51E-4A4D-9F6A-9BCFD0D310A1}"/>
               </a:ext>
             </a:extLst>
           </p:cNvPr>
@@ -6715,7 +6715,7 @@
           <p:cNvPr id="99" name="">
             <a:extLst xmlns:a="http://schemas.openxmlformats.org/drawingml/2006/main">
               <a:ext uri="{FF2B5EF4-FFF2-40B4-BE49-F238E27FC236}">
-                <a16:creationId xmlns:a16="http://schemas.microsoft.com/office/drawing/2014/main" id="{DF30A73A-E7F4-4DA4-9584-E3C94EAA86F0}"/>
+                <a16:creationId xmlns:a16="http://schemas.microsoft.com/office/drawing/2014/main" id="{EE42BD04-303A-4D76-B319-F81CF029E1C2}"/>
               </a:ext>
             </a:extLst>
           </p:cNvPr>
@@ -6772,7 +6772,7 @@
           <p:cNvPr id="100" name="">
             <a:extLst xmlns:a="http://schemas.openxmlformats.org/drawingml/2006/main">
               <a:ext uri="{FF2B5EF4-FFF2-40B4-BE49-F238E27FC236}">
-                <a16:creationId xmlns:a16="http://schemas.microsoft.com/office/drawing/2014/main" id="{B80810A2-3002-4BA2-8A47-5F674A3B813B}"/>
+                <a16:creationId xmlns:a16="http://schemas.microsoft.com/office/drawing/2014/main" id="{1158A996-0103-4A7B-AE7B-203C488A283A}"/>
               </a:ext>
             </a:extLst>
           </p:cNvPr>
@@ -6852,7 +6852,7 @@
           <p:cNvPr id="101" name="">
             <a:extLst xmlns:a="http://schemas.openxmlformats.org/drawingml/2006/main">
               <a:ext uri="{FF2B5EF4-FFF2-40B4-BE49-F238E27FC236}">
-                <a16:creationId xmlns:a16="http://schemas.microsoft.com/office/drawing/2014/main" id="{2AA02912-46B4-4E46-9547-E0120393185C}"/>
+                <a16:creationId xmlns:a16="http://schemas.microsoft.com/office/drawing/2014/main" id="{FA6D4C5E-AA35-4FEE-A70F-9904C0153813}"/>
               </a:ext>
             </a:extLst>
           </p:cNvPr>
@@ -7159,7 +7159,7 @@
           <p:nvPr/>
         </p:nvPicPr>
         <p:blipFill>
-          <a:blip xmlns:r="http://schemas.openxmlformats.org/officeDocument/2006/relationships" xmlns:a="http://schemas.openxmlformats.org/drawingml/2006/main" r:embed="R0ec165725bba492a"/>
+          <a:blip xmlns:r="http://schemas.openxmlformats.org/officeDocument/2006/relationships" xmlns:a="http://schemas.openxmlformats.org/drawingml/2006/main" r:embed="R3302214353d545cc"/>
           <a:srcRect xmlns:a="http://schemas.openxmlformats.org/drawingml/2006/main" l="0" t="0" r="0" b="0"/>
           <a:stretch xmlns:a="http://schemas.openxmlformats.org/drawingml/2006/main">
             <a:fillRect l="0" t="0" r="0" b="0"/>
@@ -7250,7 +7250,7 @@
           <p:cNvPr id="87" name="">
             <a:extLst xmlns:a="http://schemas.openxmlformats.org/drawingml/2006/main">
               <a:ext uri="{FF2B5EF4-FFF2-40B4-BE49-F238E27FC236}">
-                <a16:creationId xmlns:a16="http://schemas.microsoft.com/office/drawing/2014/main" id="{134EB011-E4BD-4B26-AE39-2E87EDFA26E1}"/>
+                <a16:creationId xmlns:a16="http://schemas.microsoft.com/office/drawing/2014/main" id="{15AF68F7-7968-435A-9D43-698CF3FC0B11}"/>
               </a:ext>
             </a:extLst>
           </p:cNvPr>
@@ -7307,7 +7307,7 @@
           <p:cNvPr id="88" name="">
             <a:extLst xmlns:a="http://schemas.openxmlformats.org/drawingml/2006/main">
               <a:ext uri="{FF2B5EF4-FFF2-40B4-BE49-F238E27FC236}">
-                <a16:creationId xmlns:a16="http://schemas.microsoft.com/office/drawing/2014/main" id="{5E8ACC4C-A621-41AC-B795-2B5D85208921}"/>
+                <a16:creationId xmlns:a16="http://schemas.microsoft.com/office/drawing/2014/main" id="{F428410A-4EAD-420E-B052-1A5DBD771E28}"/>
               </a:ext>
             </a:extLst>
           </p:cNvPr>
@@ -7364,7 +7364,7 @@
           <p:cNvPr id="89" name="">
             <a:extLst xmlns:a="http://schemas.openxmlformats.org/drawingml/2006/main">
               <a:ext uri="{FF2B5EF4-FFF2-40B4-BE49-F238E27FC236}">
-                <a16:creationId xmlns:a16="http://schemas.microsoft.com/office/drawing/2014/main" id="{F596E6E6-B337-4AD3-8725-E3B424BA53B0}"/>
+                <a16:creationId xmlns:a16="http://schemas.microsoft.com/office/drawing/2014/main" id="{5A7F444D-BE81-476D-97B7-F97EFB5EB95B}"/>
               </a:ext>
             </a:extLst>
           </p:cNvPr>
@@ -7425,7 +7425,7 @@
           <p:nvPr/>
         </p:nvPicPr>
         <p:blipFill>
-          <a:blip xmlns:r="http://schemas.openxmlformats.org/officeDocument/2006/relationships" xmlns:a="http://schemas.openxmlformats.org/drawingml/2006/main" r:embed="Re67a339489374ed3"/>
+          <a:blip xmlns:r="http://schemas.openxmlformats.org/officeDocument/2006/relationships" xmlns:a="http://schemas.openxmlformats.org/drawingml/2006/main" r:embed="Rd86fcd7c099247c0"/>
           <a:stretch xmlns:a="http://schemas.openxmlformats.org/drawingml/2006/main"/>
         </p:blipFill>
         <p:spPr>
@@ -7447,7 +7447,7 @@
           <p:nvPr/>
         </p:nvPicPr>
         <p:blipFill>
-          <a:blip xmlns:r="http://schemas.openxmlformats.org/officeDocument/2006/relationships" xmlns:a="http://schemas.openxmlformats.org/drawingml/2006/main" r:embed="Re0e0fadc9dc4477d"/>
+          <a:blip xmlns:r="http://schemas.openxmlformats.org/officeDocument/2006/relationships" xmlns:a="http://schemas.openxmlformats.org/drawingml/2006/main" r:embed="R2e4ce10a6d6c44dc"/>
           <a:stretch xmlns:a="http://schemas.openxmlformats.org/drawingml/2006/main"/>
         </p:blipFill>
         <p:spPr>
@@ -7465,7 +7465,7 @@
           <p:cNvPr id="92" name="">
             <a:extLst xmlns:a="http://schemas.openxmlformats.org/drawingml/2006/main">
               <a:ext uri="{FF2B5EF4-FFF2-40B4-BE49-F238E27FC236}">
-                <a16:creationId xmlns:a16="http://schemas.microsoft.com/office/drawing/2014/main" id="{BBDE18A1-2805-4E80-BA4A-7B86D2DAF7D8}"/>
+                <a16:creationId xmlns:a16="http://schemas.microsoft.com/office/drawing/2014/main" id="{25039F18-B23E-43D5-8C32-D5BE7BADDCD0}"/>
               </a:ext>
             </a:extLst>
           </p:cNvPr>
@@ -7522,7 +7522,7 @@
           <p:cNvPr id="93" name="">
             <a:extLst xmlns:a="http://schemas.openxmlformats.org/drawingml/2006/main">
               <a:ext uri="{FF2B5EF4-FFF2-40B4-BE49-F238E27FC236}">
-                <a16:creationId xmlns:a16="http://schemas.microsoft.com/office/drawing/2014/main" id="{097CC0BF-A5CC-4A96-A3E0-9650DE4E3361}"/>
+                <a16:creationId xmlns:a16="http://schemas.microsoft.com/office/drawing/2014/main" id="{BBEA978D-413C-4C59-B15B-E67282505893}"/>
               </a:ext>
             </a:extLst>
           </p:cNvPr>
@@ -7579,7 +7579,7 @@
           <p:cNvPr id="94" name="">
             <a:extLst xmlns:a="http://schemas.openxmlformats.org/drawingml/2006/main">
               <a:ext uri="{FF2B5EF4-FFF2-40B4-BE49-F238E27FC236}">
-                <a16:creationId xmlns:a16="http://schemas.microsoft.com/office/drawing/2014/main" id="{9FAAD6B5-8EB7-4E45-B925-179D386E3E51}"/>
+                <a16:creationId xmlns:a16="http://schemas.microsoft.com/office/drawing/2014/main" id="{7AECF649-E859-452A-994F-80D199F7D205}"/>
               </a:ext>
             </a:extLst>
           </p:cNvPr>
@@ -7636,7 +7636,7 @@
           <p:cNvPr id="95" name="">
             <a:extLst xmlns:a="http://schemas.openxmlformats.org/drawingml/2006/main">
               <a:ext uri="{FF2B5EF4-FFF2-40B4-BE49-F238E27FC236}">
-                <a16:creationId xmlns:a16="http://schemas.microsoft.com/office/drawing/2014/main" id="{962C31EC-853A-417F-BF84-DFD1C9B0E4A4}"/>
+                <a16:creationId xmlns:a16="http://schemas.microsoft.com/office/drawing/2014/main" id="{083A7339-5E77-4D01-9F2D-6E689C6A5779}"/>
               </a:ext>
             </a:extLst>
           </p:cNvPr>
@@ -7739,7 +7739,7 @@
           <p:cNvPr id="96" name="">
             <a:extLst xmlns:a="http://schemas.openxmlformats.org/drawingml/2006/main">
               <a:ext uri="{FF2B5EF4-FFF2-40B4-BE49-F238E27FC236}">
-                <a16:creationId xmlns:a16="http://schemas.microsoft.com/office/drawing/2014/main" id="{D46CE333-849E-484E-983F-41F59950DE93}"/>
+                <a16:creationId xmlns:a16="http://schemas.microsoft.com/office/drawing/2014/main" id="{9D69C6E9-DAFE-454F-BB1F-CC93AB76E901}"/>
               </a:ext>
             </a:extLst>
           </p:cNvPr>
@@ -7769,7 +7769,7 @@
           <p:cNvPr id="97" name="">
             <a:extLst xmlns:a="http://schemas.openxmlformats.org/drawingml/2006/main">
               <a:ext uri="{FF2B5EF4-FFF2-40B4-BE49-F238E27FC236}">
-                <a16:creationId xmlns:a16="http://schemas.microsoft.com/office/drawing/2014/main" id="{A4531381-3FE7-4FBE-A5A8-BE4C7ED022F1}"/>
+                <a16:creationId xmlns:a16="http://schemas.microsoft.com/office/drawing/2014/main" id="{0EAAB4B8-CC35-4C16-B596-628709EC6140}"/>
               </a:ext>
             </a:extLst>
           </p:cNvPr>
@@ -7826,7 +7826,7 @@
           <p:cNvPr id="98" name="">
             <a:extLst xmlns:a="http://schemas.openxmlformats.org/drawingml/2006/main">
               <a:ext uri="{FF2B5EF4-FFF2-40B4-BE49-F238E27FC236}">
-                <a16:creationId xmlns:a16="http://schemas.microsoft.com/office/drawing/2014/main" id="{31AE1A6D-9D33-44DC-B99D-A7B39D3B5DF9}"/>
+                <a16:creationId xmlns:a16="http://schemas.microsoft.com/office/drawing/2014/main" id="{BF1098A6-1153-4EE3-925A-04BCAFE4E675}"/>
               </a:ext>
             </a:extLst>
           </p:cNvPr>
@@ -7929,7 +7929,7 @@
           <p:cNvPr id="99" name="">
             <a:extLst xmlns:a="http://schemas.openxmlformats.org/drawingml/2006/main">
               <a:ext uri="{FF2B5EF4-FFF2-40B4-BE49-F238E27FC236}">
-                <a16:creationId xmlns:a16="http://schemas.microsoft.com/office/drawing/2014/main" id="{DD5183EE-41C2-4B30-A20B-947B4AD42323}"/>
+                <a16:creationId xmlns:a16="http://schemas.microsoft.com/office/drawing/2014/main" id="{AB79636C-EFF1-4405-90A9-63655AE73971}"/>
               </a:ext>
             </a:extLst>
           </p:cNvPr>
@@ -7986,7 +7986,7 @@
           <p:cNvPr id="100" name="">
             <a:extLst xmlns:a="http://schemas.openxmlformats.org/drawingml/2006/main">
               <a:ext uri="{FF2B5EF4-FFF2-40B4-BE49-F238E27FC236}">
-                <a16:creationId xmlns:a16="http://schemas.microsoft.com/office/drawing/2014/main" id="{32959D52-4D84-4C48-B16C-4268C30C552A}"/>
+                <a16:creationId xmlns:a16="http://schemas.microsoft.com/office/drawing/2014/main" id="{9CDC3874-4DC6-471B-83EC-69D8B46C87F7}"/>
               </a:ext>
             </a:extLst>
           </p:cNvPr>
@@ -8089,7 +8089,7 @@
           <p:cNvPr id="101" name="">
             <a:extLst xmlns:a="http://schemas.openxmlformats.org/drawingml/2006/main">
               <a:ext uri="{FF2B5EF4-FFF2-40B4-BE49-F238E27FC236}">
-                <a16:creationId xmlns:a16="http://schemas.microsoft.com/office/drawing/2014/main" id="{25CDAF81-033E-4DFA-8770-4317AE460C1B}"/>
+                <a16:creationId xmlns:a16="http://schemas.microsoft.com/office/drawing/2014/main" id="{AD50B2D5-0BE1-4157-B880-E37913D79B36}"/>
               </a:ext>
             </a:extLst>
           </p:cNvPr>
@@ -8396,7 +8396,7 @@
           <p:nvPr/>
         </p:nvPicPr>
         <p:blipFill>
-          <a:blip xmlns:r="http://schemas.openxmlformats.org/officeDocument/2006/relationships" xmlns:a="http://schemas.openxmlformats.org/drawingml/2006/main" r:embed="R357e6d5fde7e4a55"/>
+          <a:blip xmlns:r="http://schemas.openxmlformats.org/officeDocument/2006/relationships" xmlns:a="http://schemas.openxmlformats.org/drawingml/2006/main" r:embed="R04c3fc08806142a0"/>
           <a:srcRect xmlns:a="http://schemas.openxmlformats.org/drawingml/2006/main" l="0" t="0" r="0" b="0"/>
           <a:stretch xmlns:a="http://schemas.openxmlformats.org/drawingml/2006/main">
             <a:fillRect l="0" t="0" r="0" b="0"/>
@@ -8487,7 +8487,7 @@
           <p:cNvPr id="87" name="">
             <a:extLst xmlns:a="http://schemas.openxmlformats.org/drawingml/2006/main">
               <a:ext uri="{FF2B5EF4-FFF2-40B4-BE49-F238E27FC236}">
-                <a16:creationId xmlns:a16="http://schemas.microsoft.com/office/drawing/2014/main" id="{9F5E2230-AF2A-45C6-84BF-3ABFD11E52E7}"/>
+                <a16:creationId xmlns:a16="http://schemas.microsoft.com/office/drawing/2014/main" id="{36E26F35-ECAB-4F8B-A652-2326B36563F4}"/>
               </a:ext>
             </a:extLst>
           </p:cNvPr>
@@ -8544,7 +8544,7 @@
           <p:cNvPr id="88" name="">
             <a:extLst xmlns:a="http://schemas.openxmlformats.org/drawingml/2006/main">
               <a:ext uri="{FF2B5EF4-FFF2-40B4-BE49-F238E27FC236}">
-                <a16:creationId xmlns:a16="http://schemas.microsoft.com/office/drawing/2014/main" id="{10207828-D34B-40B4-AD3B-6A259A3E9FB3}"/>
+                <a16:creationId xmlns:a16="http://schemas.microsoft.com/office/drawing/2014/main" id="{25FCFA80-C1F6-4CBF-871A-E0F112516BA3}"/>
               </a:ext>
             </a:extLst>
           </p:cNvPr>
@@ -8601,7 +8601,7 @@
           <p:cNvPr id="89" name="">
             <a:extLst xmlns:a="http://schemas.openxmlformats.org/drawingml/2006/main">
               <a:ext uri="{FF2B5EF4-FFF2-40B4-BE49-F238E27FC236}">
-                <a16:creationId xmlns:a16="http://schemas.microsoft.com/office/drawing/2014/main" id="{819A52D8-8D29-4CC4-81D2-F6B03E9D95F0}"/>
+                <a16:creationId xmlns:a16="http://schemas.microsoft.com/office/drawing/2014/main" id="{34931A9D-B750-4556-A72F-2380470F575C}"/>
               </a:ext>
             </a:extLst>
           </p:cNvPr>
@@ -8662,7 +8662,7 @@
           <p:nvPr/>
         </p:nvPicPr>
         <p:blipFill>
-          <a:blip xmlns:r="http://schemas.openxmlformats.org/officeDocument/2006/relationships" xmlns:a="http://schemas.openxmlformats.org/drawingml/2006/main" r:embed="R1b415a7dab524ca9"/>
+          <a:blip xmlns:r="http://schemas.openxmlformats.org/officeDocument/2006/relationships" xmlns:a="http://schemas.openxmlformats.org/drawingml/2006/main" r:embed="Ra2974b5e71e046e4"/>
           <a:stretch xmlns:a="http://schemas.openxmlformats.org/drawingml/2006/main"/>
         </p:blipFill>
         <p:spPr>
@@ -8680,7 +8680,7 @@
           <p:cNvPr id="91" name="">
             <a:extLst xmlns:a="http://schemas.openxmlformats.org/drawingml/2006/main">
               <a:ext uri="{FF2B5EF4-FFF2-40B4-BE49-F238E27FC236}">
-                <a16:creationId xmlns:a16="http://schemas.microsoft.com/office/drawing/2014/main" id="{79C0B00E-C585-453D-BCAF-46B4E7B35790}"/>
+                <a16:creationId xmlns:a16="http://schemas.microsoft.com/office/drawing/2014/main" id="{D4EC5755-25C3-453B-B86F-E84BCD2820ED}"/>
               </a:ext>
             </a:extLst>
           </p:cNvPr>
@@ -8737,7 +8737,7 @@
           <p:cNvPr id="92" name="">
             <a:extLst xmlns:a="http://schemas.openxmlformats.org/drawingml/2006/main">
               <a:ext uri="{FF2B5EF4-FFF2-40B4-BE49-F238E27FC236}">
-                <a16:creationId xmlns:a16="http://schemas.microsoft.com/office/drawing/2014/main" id="{8DD7A17A-7567-41E3-85E3-4F9FD0A61F26}"/>
+                <a16:creationId xmlns:a16="http://schemas.microsoft.com/office/drawing/2014/main" id="{4199E707-25F8-4786-8599-C9D3DF42E749}"/>
               </a:ext>
             </a:extLst>
           </p:cNvPr>
@@ -8794,7 +8794,7 @@
           <p:cNvPr id="93" name="">
             <a:extLst xmlns:a="http://schemas.openxmlformats.org/drawingml/2006/main">
               <a:ext uri="{FF2B5EF4-FFF2-40B4-BE49-F238E27FC236}">
-                <a16:creationId xmlns:a16="http://schemas.microsoft.com/office/drawing/2014/main" id="{2E202A1C-F518-4C6D-9277-C6BD4E29CF31}"/>
+                <a16:creationId xmlns:a16="http://schemas.microsoft.com/office/drawing/2014/main" id="{79A2D0B7-75A7-4F58-A890-DF74BE514746}"/>
               </a:ext>
             </a:extLst>
           </p:cNvPr>
@@ -8897,7 +8897,7 @@
           <p:cNvPr id="94" name="">
             <a:extLst xmlns:a="http://schemas.openxmlformats.org/drawingml/2006/main">
               <a:ext uri="{FF2B5EF4-FFF2-40B4-BE49-F238E27FC236}">
-                <a16:creationId xmlns:a16="http://schemas.microsoft.com/office/drawing/2014/main" id="{E18CDEF3-5F79-4C44-9662-D4E9FE6076D4}"/>
+                <a16:creationId xmlns:a16="http://schemas.microsoft.com/office/drawing/2014/main" id="{FC91E57F-7F77-4B72-BE63-6039C1C8637E}"/>
               </a:ext>
             </a:extLst>
           </p:cNvPr>
@@ -8958,7 +8958,7 @@
           <p:cNvPr id="95" name="">
             <a:extLst xmlns:a="http://schemas.openxmlformats.org/drawingml/2006/main">
               <a:ext uri="{FF2B5EF4-FFF2-40B4-BE49-F238E27FC236}">
-                <a16:creationId xmlns:a16="http://schemas.microsoft.com/office/drawing/2014/main" id="{E6B645DD-9A65-4F27-953D-36874C82764D}"/>
+                <a16:creationId xmlns:a16="http://schemas.microsoft.com/office/drawing/2014/main" id="{8FDCF781-200E-4ED6-82EB-9FF081609313}"/>
               </a:ext>
             </a:extLst>
           </p:cNvPr>
@@ -9019,7 +9019,7 @@
           <p:cNvPr id="96" name="">
             <a:extLst xmlns:a="http://schemas.openxmlformats.org/drawingml/2006/main">
               <a:ext uri="{FF2B5EF4-FFF2-40B4-BE49-F238E27FC236}">
-                <a16:creationId xmlns:a16="http://schemas.microsoft.com/office/drawing/2014/main" id="{4800AEE0-5654-4191-86B8-D049A0FA156E}"/>
+                <a16:creationId xmlns:a16="http://schemas.microsoft.com/office/drawing/2014/main" id="{32188CB5-4739-4314-92D5-D1ACA03BB08C}"/>
               </a:ext>
             </a:extLst>
           </p:cNvPr>
@@ -9134,7 +9134,7 @@
           <p:cNvPr id="99" name="">
             <a:extLst xmlns:a="http://schemas.openxmlformats.org/drawingml/2006/main">
               <a:ext uri="{FF2B5EF4-FFF2-40B4-BE49-F238E27FC236}">
-                <a16:creationId xmlns:a16="http://schemas.microsoft.com/office/drawing/2014/main" id="{3888BC64-4B23-42E5-9CD0-3D6BAB25C00F}"/>
+                <a16:creationId xmlns:a16="http://schemas.microsoft.com/office/drawing/2014/main" id="{187DD68B-9710-434C-B98B-EDEC58D04CA0}"/>
               </a:ext>
             </a:extLst>
           </p:cNvPr>
@@ -9191,7 +9191,7 @@
           <p:cNvPr id="100" name="">
             <a:extLst xmlns:a="http://schemas.openxmlformats.org/drawingml/2006/main">
               <a:ext uri="{FF2B5EF4-FFF2-40B4-BE49-F238E27FC236}">
-                <a16:creationId xmlns:a16="http://schemas.microsoft.com/office/drawing/2014/main" id="{51E90F1E-AF64-4FF3-B862-E3E3CED9F44E}"/>
+                <a16:creationId xmlns:a16="http://schemas.microsoft.com/office/drawing/2014/main" id="{DB894234-E54B-4556-8DBC-552FCA2DB755}"/>
               </a:ext>
             </a:extLst>
           </p:cNvPr>
@@ -9294,7 +9294,7 @@
           <p:cNvPr id="101" name="">
             <a:extLst xmlns:a="http://schemas.openxmlformats.org/drawingml/2006/main">
               <a:ext uri="{FF2B5EF4-FFF2-40B4-BE49-F238E27FC236}">
-                <a16:creationId xmlns:a16="http://schemas.microsoft.com/office/drawing/2014/main" id="{4B43F43A-AA02-4E99-8FA0-7832FCA60EB9}"/>
+                <a16:creationId xmlns:a16="http://schemas.microsoft.com/office/drawing/2014/main" id="{8AD2B12E-418D-41AE-B17C-05A99A730638}"/>
               </a:ext>
             </a:extLst>
           </p:cNvPr>
@@ -9601,7 +9601,7 @@
           <p:nvPr/>
         </p:nvPicPr>
         <p:blipFill>
-          <a:blip xmlns:r="http://schemas.openxmlformats.org/officeDocument/2006/relationships" xmlns:a="http://schemas.openxmlformats.org/drawingml/2006/main" r:embed="R451d7e12025d4c27"/>
+          <a:blip xmlns:r="http://schemas.openxmlformats.org/officeDocument/2006/relationships" xmlns:a="http://schemas.openxmlformats.org/drawingml/2006/main" r:embed="Rff68f58a5de84651"/>
           <a:srcRect xmlns:a="http://schemas.openxmlformats.org/drawingml/2006/main" l="0" t="0" r="0" b="0"/>
           <a:stretch xmlns:a="http://schemas.openxmlformats.org/drawingml/2006/main">
             <a:fillRect l="0" t="0" r="0" b="0"/>
@@ -9692,7 +9692,7 @@
           <p:cNvPr id="87" name="">
             <a:extLst xmlns:a="http://schemas.openxmlformats.org/drawingml/2006/main">
               <a:ext uri="{FF2B5EF4-FFF2-40B4-BE49-F238E27FC236}">
-                <a16:creationId xmlns:a16="http://schemas.microsoft.com/office/drawing/2014/main" id="{C10BDE94-987E-4AF9-97C9-1A214CFB832B}"/>
+                <a16:creationId xmlns:a16="http://schemas.microsoft.com/office/drawing/2014/main" id="{9EB52429-89D2-42F7-92B5-2F10CE0D2A80}"/>
               </a:ext>
             </a:extLst>
           </p:cNvPr>
@@ -9749,7 +9749,7 @@
           <p:cNvPr id="88" name="">
             <a:extLst xmlns:a="http://schemas.openxmlformats.org/drawingml/2006/main">
               <a:ext uri="{FF2B5EF4-FFF2-40B4-BE49-F238E27FC236}">
-                <a16:creationId xmlns:a16="http://schemas.microsoft.com/office/drawing/2014/main" id="{CA4809C5-40B3-4768-A171-371271173169}"/>
+                <a16:creationId xmlns:a16="http://schemas.microsoft.com/office/drawing/2014/main" id="{F156CEF2-7B92-45B5-96B9-4294C606B9D6}"/>
               </a:ext>
             </a:extLst>
           </p:cNvPr>
@@ -9806,7 +9806,7 @@
           <p:cNvPr id="89" name="">
             <a:extLst xmlns:a="http://schemas.openxmlformats.org/drawingml/2006/main">
               <a:ext uri="{FF2B5EF4-FFF2-40B4-BE49-F238E27FC236}">
-                <a16:creationId xmlns:a16="http://schemas.microsoft.com/office/drawing/2014/main" id="{4B192A74-C2C3-46BB-9E8B-9A9C91FA356F}"/>
+                <a16:creationId xmlns:a16="http://schemas.microsoft.com/office/drawing/2014/main" id="{75DE86DD-2929-4843-A1B2-44EF531DF163}"/>
               </a:ext>
             </a:extLst>
           </p:cNvPr>
@@ -9863,7 +9863,7 @@
           <p:cNvPr id="90" name="">
             <a:extLst xmlns:a="http://schemas.openxmlformats.org/drawingml/2006/main">
               <a:ext uri="{FF2B5EF4-FFF2-40B4-BE49-F238E27FC236}">
-                <a16:creationId xmlns:a16="http://schemas.microsoft.com/office/drawing/2014/main" id="{1187D523-0B17-406A-BCFA-F7F45E5ACA2D}"/>
+                <a16:creationId xmlns:a16="http://schemas.microsoft.com/office/drawing/2014/main" id="{B0888E0C-6FFF-47AD-B76B-51195B7E5BC1}"/>
               </a:ext>
             </a:extLst>
           </p:cNvPr>
@@ -9924,7 +9924,7 @@
           <p:cNvPr id="91" name="">
             <a:extLst xmlns:a="http://schemas.openxmlformats.org/drawingml/2006/main">
               <a:ext uri="{FF2B5EF4-FFF2-40B4-BE49-F238E27FC236}">
-                <a16:creationId xmlns:a16="http://schemas.microsoft.com/office/drawing/2014/main" id="{A468B233-BE74-43FD-9ED4-006118B7E700}"/>
+                <a16:creationId xmlns:a16="http://schemas.microsoft.com/office/drawing/2014/main" id="{4DFCFCF0-EA65-4674-9595-95E87807FA8D}"/>
               </a:ext>
             </a:extLst>
           </p:cNvPr>
@@ -9985,7 +9985,7 @@
           <p:cNvPr id="92" name="">
             <a:extLst xmlns:a="http://schemas.openxmlformats.org/drawingml/2006/main">
               <a:ext uri="{FF2B5EF4-FFF2-40B4-BE49-F238E27FC236}">
-                <a16:creationId xmlns:a16="http://schemas.microsoft.com/office/drawing/2014/main" id="{D992FCD4-A690-4A97-9744-0CA91807E991}"/>
+                <a16:creationId xmlns:a16="http://schemas.microsoft.com/office/drawing/2014/main" id="{5CD2B2B5-CF88-4FF6-BD6E-9A79424B30D7}"/>
               </a:ext>
             </a:extLst>
           </p:cNvPr>
@@ -10046,7 +10046,7 @@
           <p:cNvPr id="93" name="">
             <a:extLst xmlns:a="http://schemas.openxmlformats.org/drawingml/2006/main">
               <a:ext uri="{FF2B5EF4-FFF2-40B4-BE49-F238E27FC236}">
-                <a16:creationId xmlns:a16="http://schemas.microsoft.com/office/drawing/2014/main" id="{41ED811B-7643-44AA-B71B-445F012CC2FC}"/>
+                <a16:creationId xmlns:a16="http://schemas.microsoft.com/office/drawing/2014/main" id="{A4A32AA2-42E4-48B4-951C-3C4B71C023E0}"/>
               </a:ext>
             </a:extLst>
           </p:cNvPr>
@@ -10182,7 +10182,7 @@
           <p:cNvPr id="97" name="">
             <a:extLst xmlns:a="http://schemas.openxmlformats.org/drawingml/2006/main">
               <a:ext uri="{FF2B5EF4-FFF2-40B4-BE49-F238E27FC236}">
-                <a16:creationId xmlns:a16="http://schemas.microsoft.com/office/drawing/2014/main" id="{D0FA2752-F572-4EE6-AA41-6BA12B682324}"/>
+                <a16:creationId xmlns:a16="http://schemas.microsoft.com/office/drawing/2014/main" id="{448CC66E-E396-4197-9CCE-FA92741DCD9F}"/>
               </a:ext>
             </a:extLst>
           </p:cNvPr>
@@ -10516,7 +10516,7 @@
           <p:cNvPr id="99" name="">
             <a:extLst xmlns:a="http://schemas.openxmlformats.org/drawingml/2006/main">
               <a:ext uri="{FF2B5EF4-FFF2-40B4-BE49-F238E27FC236}">
-                <a16:creationId xmlns:a16="http://schemas.microsoft.com/office/drawing/2014/main" id="{B2A1D949-85CA-4CD8-8896-860FF375C7DA}"/>
+                <a16:creationId xmlns:a16="http://schemas.microsoft.com/office/drawing/2014/main" id="{7EDD873E-AF57-4F99-A059-0C6D74DAFC69}"/>
               </a:ext>
             </a:extLst>
           </p:cNvPr>
@@ -10823,7 +10823,7 @@
           <p:nvPr/>
         </p:nvPicPr>
         <p:blipFill>
-          <a:blip xmlns:r="http://schemas.openxmlformats.org/officeDocument/2006/relationships" xmlns:a="http://schemas.openxmlformats.org/drawingml/2006/main" r:embed="Rde942e3be6344c9c"/>
+          <a:blip xmlns:r="http://schemas.openxmlformats.org/officeDocument/2006/relationships" xmlns:a="http://schemas.openxmlformats.org/drawingml/2006/main" r:embed="Re8f6c01316da4a0c"/>
           <a:srcRect xmlns:a="http://schemas.openxmlformats.org/drawingml/2006/main" l="0" t="0" r="0" b="0"/>
           <a:stretch xmlns:a="http://schemas.openxmlformats.org/drawingml/2006/main">
             <a:fillRect l="0" t="0" r="0" b="0"/>
@@ -10914,7 +10914,7 @@
           <p:cNvPr id="87" name="">
             <a:extLst xmlns:a="http://schemas.openxmlformats.org/drawingml/2006/main">
               <a:ext uri="{FF2B5EF4-FFF2-40B4-BE49-F238E27FC236}">
-                <a16:creationId xmlns:a16="http://schemas.microsoft.com/office/drawing/2014/main" id="{E026B76D-B1D9-424D-B1FA-E27D36E62C26}"/>
+                <a16:creationId xmlns:a16="http://schemas.microsoft.com/office/drawing/2014/main" id="{ADB8ABB9-2581-400D-8258-3EEBD1C821B7}"/>
               </a:ext>
             </a:extLst>
           </p:cNvPr>
@@ -10971,7 +10971,7 @@
           <p:cNvPr id="88" name="">
             <a:extLst xmlns:a="http://schemas.openxmlformats.org/drawingml/2006/main">
               <a:ext uri="{FF2B5EF4-FFF2-40B4-BE49-F238E27FC236}">
-                <a16:creationId xmlns:a16="http://schemas.microsoft.com/office/drawing/2014/main" id="{CB466950-8621-4165-8390-CDE04D320DB1}"/>
+                <a16:creationId xmlns:a16="http://schemas.microsoft.com/office/drawing/2014/main" id="{DB38DE3F-D1A5-46DA-8585-2F31ACFB7150}"/>
               </a:ext>
             </a:extLst>
           </p:cNvPr>
@@ -11028,7 +11028,7 @@
           <p:cNvPr id="89" name="">
             <a:extLst xmlns:a="http://schemas.openxmlformats.org/drawingml/2006/main">
               <a:ext uri="{FF2B5EF4-FFF2-40B4-BE49-F238E27FC236}">
-                <a16:creationId xmlns:a16="http://schemas.microsoft.com/office/drawing/2014/main" id="{CA86C8C6-9D72-471F-A4CD-AB0058777D5A}"/>
+                <a16:creationId xmlns:a16="http://schemas.microsoft.com/office/drawing/2014/main" id="{B67EB88F-E8D6-4094-A798-922F5D5B1D31}"/>
               </a:ext>
             </a:extLst>
           </p:cNvPr>
@@ -11085,7 +11085,7 @@
           <p:cNvPr id="90" name="">
             <a:extLst xmlns:a="http://schemas.openxmlformats.org/drawingml/2006/main">
               <a:ext uri="{FF2B5EF4-FFF2-40B4-BE49-F238E27FC236}">
-                <a16:creationId xmlns:a16="http://schemas.microsoft.com/office/drawing/2014/main" id="{803922B5-4F62-4CC2-AA04-C54CBCA994BF}"/>
+                <a16:creationId xmlns:a16="http://schemas.microsoft.com/office/drawing/2014/main" id="{45BEFC30-92E6-4BC8-8E0C-83346E7EA05D}"/>
               </a:ext>
             </a:extLst>
           </p:cNvPr>
@@ -11142,7 +11142,7 @@
           <p:cNvPr id="91" name="">
             <a:extLst xmlns:a="http://schemas.openxmlformats.org/drawingml/2006/main">
               <a:ext uri="{FF2B5EF4-FFF2-40B4-BE49-F238E27FC236}">
-                <a16:creationId xmlns:a16="http://schemas.microsoft.com/office/drawing/2014/main" id="{DC34AD8B-9000-4E26-9064-26BAD25637A0}"/>
+                <a16:creationId xmlns:a16="http://schemas.microsoft.com/office/drawing/2014/main" id="{6CA8CCF0-CDA0-41C2-AA18-A602F0E6D730}"/>
               </a:ext>
             </a:extLst>
           </p:cNvPr>
@@ -11212,7 +11212,7 @@
                 <a:ea typeface="맑은 고딕"/>
                 <a:cs typeface="맑은 고딕"/>
               </a:rPr>
-              <a:t>핵심 실행을 돕는 기능으로 묶고, 별도 화면 설명은 생략했다.</a:t>
+              <a:t>생활 조건을 계획에 반영하고, 목표와 실행 기록을 계속 관리한다.</a:t>
             </a:r>
           </a:p>
         </p:txBody>
@@ -11499,7 +11499,7 @@
           <p:cNvPr id="93" name="">
             <a:extLst xmlns:a="http://schemas.openxmlformats.org/drawingml/2006/main">
               <a:ext uri="{FF2B5EF4-FFF2-40B4-BE49-F238E27FC236}">
-                <a16:creationId xmlns:a16="http://schemas.microsoft.com/office/drawing/2014/main" id="{325C3BD2-07BF-473D-9756-D94A3BC988BE}"/>
+                <a16:creationId xmlns:a16="http://schemas.microsoft.com/office/drawing/2014/main" id="{E4FC2C97-121C-4D50-9B46-F4C4D40B5D11}"/>
               </a:ext>
             </a:extLst>
           </p:cNvPr>
@@ -11546,7 +11546,7 @@
                 <a:ea typeface="맑은 고딕"/>
                 <a:cs typeface="맑은 고딕"/>
               </a:rPr>
-              <a:t>위 항목은 화면이나 진입 버튼이 있어도 완료 기능으로 포함하지 않았다.</a:t>
+              <a:t>위 항목은 아직 사용할 수 없거나, 전체 사용 흐름이 완성되지 않았다.</a:t>
             </a:r>
           </a:p>
         </p:txBody>
@@ -11806,7 +11806,7 @@
           <p:nvPr/>
         </p:nvPicPr>
         <p:blipFill>
-          <a:blip xmlns:r="http://schemas.openxmlformats.org/officeDocument/2006/relationships" xmlns:a="http://schemas.openxmlformats.org/drawingml/2006/main" r:embed="R98c042adbdc74ec0"/>
+          <a:blip xmlns:r="http://schemas.openxmlformats.org/officeDocument/2006/relationships" xmlns:a="http://schemas.openxmlformats.org/drawingml/2006/main" r:embed="R934f581070fc42dc"/>
           <a:srcRect xmlns:a="http://schemas.openxmlformats.org/drawingml/2006/main" l="0" t="0" r="0" b="0"/>
           <a:stretch xmlns:a="http://schemas.openxmlformats.org/drawingml/2006/main">
             <a:fillRect l="0" t="0" r="0" b="0"/>
@@ -11897,7 +11897,7 @@
           <p:cNvPr id="87" name="">
             <a:extLst xmlns:a="http://schemas.openxmlformats.org/drawingml/2006/main">
               <a:ext uri="{FF2B5EF4-FFF2-40B4-BE49-F238E27FC236}">
-                <a16:creationId xmlns:a16="http://schemas.microsoft.com/office/drawing/2014/main" id="{67622DDE-842F-477E-9369-35BB2C5E01F7}"/>
+                <a16:creationId xmlns:a16="http://schemas.microsoft.com/office/drawing/2014/main" id="{24D1E2BC-51CC-4B56-AAAC-9076DC199BFC}"/>
               </a:ext>
             </a:extLst>
           </p:cNvPr>
@@ -11944,7 +11944,7 @@
                 <a:ea typeface="맑은 고딕"/>
                 <a:cs typeface="맑은 고딕"/>
               </a:rPr>
-              <a:t>목표를 계획으로, 끊긴 실행을 다시 시작으로</a:t>
+              <a:t>목표 계획과 실행 회복 흐름</a:t>
             </a:r>
           </a:p>
         </p:txBody>
@@ -11954,7 +11954,7 @@
           <p:cNvPr id="88" name="">
             <a:extLst xmlns:a="http://schemas.openxmlformats.org/drawingml/2006/main">
               <a:ext uri="{FF2B5EF4-FFF2-40B4-BE49-F238E27FC236}">
-                <a16:creationId xmlns:a16="http://schemas.microsoft.com/office/drawing/2014/main" id="{AC93CFEC-48E1-4D22-919D-2BF91175B507}"/>
+                <a16:creationId xmlns:a16="http://schemas.microsoft.com/office/drawing/2014/main" id="{0D0C55DC-EBD7-4090-A629-E22B7E130411}"/>
               </a:ext>
             </a:extLst>
           </p:cNvPr>
@@ -12011,7 +12011,7 @@
           <p:cNvPr id="89" name="">
             <a:extLst xmlns:a="http://schemas.openxmlformats.org/drawingml/2006/main">
               <a:ext uri="{FF2B5EF4-FFF2-40B4-BE49-F238E27FC236}">
-                <a16:creationId xmlns:a16="http://schemas.microsoft.com/office/drawing/2014/main" id="{D56AC180-145B-4A29-8A4B-AB80D3A86B00}"/>
+                <a16:creationId xmlns:a16="http://schemas.microsoft.com/office/drawing/2014/main" id="{FCDE6A9A-9722-4FBE-B95F-D23E859C2CA3}"/>
               </a:ext>
             </a:extLst>
           </p:cNvPr>
@@ -12068,7 +12068,7 @@
           <p:cNvPr id="90" name="">
             <a:extLst xmlns:a="http://schemas.openxmlformats.org/drawingml/2006/main">
               <a:ext uri="{FF2B5EF4-FFF2-40B4-BE49-F238E27FC236}">
-                <a16:creationId xmlns:a16="http://schemas.microsoft.com/office/drawing/2014/main" id="{21D7E033-C4DD-4E25-B28E-D1194292D72A}"/>
+                <a16:creationId xmlns:a16="http://schemas.microsoft.com/office/drawing/2014/main" id="{FA435629-A812-4B20-B1A4-C7DC9C43C8E5}"/>
               </a:ext>
             </a:extLst>
           </p:cNvPr>
@@ -12148,7 +12148,7 @@
           <p:cNvPr id="91" name="">
             <a:extLst xmlns:a="http://schemas.openxmlformats.org/drawingml/2006/main">
               <a:ext uri="{FF2B5EF4-FFF2-40B4-BE49-F238E27FC236}">
-                <a16:creationId xmlns:a16="http://schemas.microsoft.com/office/drawing/2014/main" id="{6D4618F0-5355-482F-A96A-10B6F015CFDE}"/>
+                <a16:creationId xmlns:a16="http://schemas.microsoft.com/office/drawing/2014/main" id="{E8E1509D-6288-4A7F-88BA-744874E1021B}"/>
               </a:ext>
             </a:extLst>
           </p:cNvPr>
@@ -12191,7 +12191,7 @@
           <p:cNvPr id="92" name="">
             <a:extLst xmlns:a="http://schemas.openxmlformats.org/drawingml/2006/main">
               <a:ext uri="{FF2B5EF4-FFF2-40B4-BE49-F238E27FC236}">
-                <a16:creationId xmlns:a16="http://schemas.microsoft.com/office/drawing/2014/main" id="{A7B5ABE0-1856-40BF-B07D-916BCCB77716}"/>
+                <a16:creationId xmlns:a16="http://schemas.microsoft.com/office/drawing/2014/main" id="{4B684200-6370-40AA-A507-806D2674D364}"/>
               </a:ext>
             </a:extLst>
           </p:cNvPr>
@@ -12234,7 +12234,7 @@
           <p:cNvPr id="93" name="">
             <a:extLst xmlns:a="http://schemas.openxmlformats.org/drawingml/2006/main">
               <a:ext uri="{FF2B5EF4-FFF2-40B4-BE49-F238E27FC236}">
-                <a16:creationId xmlns:a16="http://schemas.microsoft.com/office/drawing/2014/main" id="{05E9C1BB-3DEF-4C9A-ABAB-803887F97975}"/>
+                <a16:creationId xmlns:a16="http://schemas.microsoft.com/office/drawing/2014/main" id="{06FC9AC4-2370-4D93-931C-B8C308E201ED}"/>
               </a:ext>
             </a:extLst>
           </p:cNvPr>
@@ -12277,7 +12277,7 @@
           <p:cNvPr id="94" name="">
             <a:extLst xmlns:a="http://schemas.openxmlformats.org/drawingml/2006/main">
               <a:ext uri="{FF2B5EF4-FFF2-40B4-BE49-F238E27FC236}">
-                <a16:creationId xmlns:a16="http://schemas.microsoft.com/office/drawing/2014/main" id="{553EBB67-05B4-45BA-9597-CD0C966875B7}"/>
+                <a16:creationId xmlns:a16="http://schemas.microsoft.com/office/drawing/2014/main" id="{59E35A67-AEC7-4F2F-9FC1-D4D9536B0750}"/>
               </a:ext>
             </a:extLst>
           </p:cNvPr>
@@ -12320,7 +12320,7 @@
           <p:cNvPr id="95" name="">
             <a:extLst xmlns:a="http://schemas.openxmlformats.org/drawingml/2006/main">
               <a:ext uri="{FF2B5EF4-FFF2-40B4-BE49-F238E27FC236}">
-                <a16:creationId xmlns:a16="http://schemas.microsoft.com/office/drawing/2014/main" id="{2780D6EF-766E-4F38-9F2B-FBD90ACE92A0}"/>
+                <a16:creationId xmlns:a16="http://schemas.microsoft.com/office/drawing/2014/main" id="{8CA1EFAA-43C4-4768-8B55-DBE08CCEE044}"/>
               </a:ext>
             </a:extLst>
           </p:cNvPr>
@@ -12377,7 +12377,7 @@
           <p:cNvPr id="96" name="">
             <a:extLst xmlns:a="http://schemas.openxmlformats.org/drawingml/2006/main">
               <a:ext uri="{FF2B5EF4-FFF2-40B4-BE49-F238E27FC236}">
-                <a16:creationId xmlns:a16="http://schemas.microsoft.com/office/drawing/2014/main" id="{28699CB9-8557-4869-89E2-E43828B53054}"/>
+                <a16:creationId xmlns:a16="http://schemas.microsoft.com/office/drawing/2014/main" id="{77172029-5FE3-415A-8D57-74E88FF858FF}"/>
               </a:ext>
             </a:extLst>
           </p:cNvPr>
@@ -12434,7 +12434,7 @@
           <p:cNvPr id="97" name="">
             <a:extLst xmlns:a="http://schemas.openxmlformats.org/drawingml/2006/main">
               <a:ext uri="{FF2B5EF4-FFF2-40B4-BE49-F238E27FC236}">
-                <a16:creationId xmlns:a16="http://schemas.microsoft.com/office/drawing/2014/main" id="{AB2B91FC-1ADC-41FA-AC3F-CACDE6AFF8F4}"/>
+                <a16:creationId xmlns:a16="http://schemas.microsoft.com/office/drawing/2014/main" id="{88DF20EE-870F-4F39-B3ED-ECA81B7FDF68}"/>
               </a:ext>
             </a:extLst>
           </p:cNvPr>
@@ -12491,7 +12491,7 @@
           <p:cNvPr id="98" name="">
             <a:extLst xmlns:a="http://schemas.openxmlformats.org/drawingml/2006/main">
               <a:ext uri="{FF2B5EF4-FFF2-40B4-BE49-F238E27FC236}">
-                <a16:creationId xmlns:a16="http://schemas.microsoft.com/office/drawing/2014/main" id="{986802E3-3779-4B85-BBF8-53019E9BD893}"/>
+                <a16:creationId xmlns:a16="http://schemas.microsoft.com/office/drawing/2014/main" id="{0C10E245-D849-460A-8BC6-5F9BEE990CA9}"/>
               </a:ext>
             </a:extLst>
           </p:cNvPr>
@@ -12548,7 +12548,7 @@
           <p:cNvPr id="99" name="">
             <a:extLst xmlns:a="http://schemas.openxmlformats.org/drawingml/2006/main">
               <a:ext uri="{FF2B5EF4-FFF2-40B4-BE49-F238E27FC236}">
-                <a16:creationId xmlns:a16="http://schemas.microsoft.com/office/drawing/2014/main" id="{FDA16A45-EACA-4979-9C98-1E8749F56903}"/>
+                <a16:creationId xmlns:a16="http://schemas.microsoft.com/office/drawing/2014/main" id="{5E760252-1C03-4626-B894-CDA59348FF93}"/>
               </a:ext>
             </a:extLst>
           </p:cNvPr>
@@ -12605,7 +12605,7 @@
           <p:cNvPr id="100" name="">
             <a:extLst xmlns:a="http://schemas.openxmlformats.org/drawingml/2006/main">
               <a:ext uri="{FF2B5EF4-FFF2-40B4-BE49-F238E27FC236}">
-                <a16:creationId xmlns:a16="http://schemas.microsoft.com/office/drawing/2014/main" id="{735A8CA6-3AD6-4394-85F1-885B81805EA7}"/>
+                <a16:creationId xmlns:a16="http://schemas.microsoft.com/office/drawing/2014/main" id="{2CDEB3C9-EB6D-454C-891A-D4CD3BF55F26}"/>
               </a:ext>
             </a:extLst>
           </p:cNvPr>
@@ -12662,7 +12662,7 @@
           <p:cNvPr id="101" name="">
             <a:extLst xmlns:a="http://schemas.openxmlformats.org/drawingml/2006/main">
               <a:ext uri="{FF2B5EF4-FFF2-40B4-BE49-F238E27FC236}">
-                <a16:creationId xmlns:a16="http://schemas.microsoft.com/office/drawing/2014/main" id="{47557E5D-4CE2-4759-8A07-5EB0BD792F65}"/>
+                <a16:creationId xmlns:a16="http://schemas.microsoft.com/office/drawing/2014/main" id="{17029D7A-9E82-4FAF-B338-E8643C60D4B3}"/>
               </a:ext>
             </a:extLst>
           </p:cNvPr>
@@ -12719,7 +12719,7 @@
           <p:cNvPr id="102" name="">
             <a:extLst xmlns:a="http://schemas.openxmlformats.org/drawingml/2006/main">
               <a:ext uri="{FF2B5EF4-FFF2-40B4-BE49-F238E27FC236}">
-                <a16:creationId xmlns:a16="http://schemas.microsoft.com/office/drawing/2014/main" id="{664FDC6F-B869-472C-9E05-F585E54EEE73}"/>
+                <a16:creationId xmlns:a16="http://schemas.microsoft.com/office/drawing/2014/main" id="{A5E91860-7743-473F-8744-740D81060914}"/>
               </a:ext>
             </a:extLst>
           </p:cNvPr>
@@ -12851,7 +12851,7 @@
           <p:cNvPr id="106" name="">
             <a:extLst xmlns:a="http://schemas.openxmlformats.org/drawingml/2006/main">
               <a:ext uri="{FF2B5EF4-FFF2-40B4-BE49-F238E27FC236}">
-                <a16:creationId xmlns:a16="http://schemas.microsoft.com/office/drawing/2014/main" id="{B23039A6-02B4-4A92-A9C5-4274B1B75FF5}"/>
+                <a16:creationId xmlns:a16="http://schemas.microsoft.com/office/drawing/2014/main" id="{6E58BAF0-66C4-4E74-82B6-9129189DA999}"/>
               </a:ext>
             </a:extLst>
           </p:cNvPr>
@@ -12965,7 +12965,7 @@
           <p:cNvPr id="109" name="">
             <a:extLst xmlns:a="http://schemas.openxmlformats.org/drawingml/2006/main">
               <a:ext uri="{FF2B5EF4-FFF2-40B4-BE49-F238E27FC236}">
-                <a16:creationId xmlns:a16="http://schemas.microsoft.com/office/drawing/2014/main" id="{08D0A3FF-7A25-4ADE-BD91-5A4E4A9892DD}"/>
+                <a16:creationId xmlns:a16="http://schemas.microsoft.com/office/drawing/2014/main" id="{52A486A5-4DA3-41EC-A480-2ECA1CB3CC02}"/>
               </a:ext>
             </a:extLst>
           </p:cNvPr>
@@ -13022,7 +13022,7 @@
           <p:cNvPr id="110" name="">
             <a:extLst xmlns:a="http://schemas.openxmlformats.org/drawingml/2006/main">
               <a:ext uri="{FF2B5EF4-FFF2-40B4-BE49-F238E27FC236}">
-                <a16:creationId xmlns:a16="http://schemas.microsoft.com/office/drawing/2014/main" id="{C6621057-1A4A-4D03-813B-B139C8FAE611}"/>
+                <a16:creationId xmlns:a16="http://schemas.microsoft.com/office/drawing/2014/main" id="{74F92AC0-E30C-42BA-804D-BFAB672B1FBE}"/>
               </a:ext>
             </a:extLst>
           </p:cNvPr>
@@ -13329,7 +13329,7 @@
           <p:nvPr/>
         </p:nvPicPr>
         <p:blipFill>
-          <a:blip xmlns:r="http://schemas.openxmlformats.org/officeDocument/2006/relationships" xmlns:a="http://schemas.openxmlformats.org/drawingml/2006/main" r:embed="R3a76e58a129a4fbb"/>
+          <a:blip xmlns:r="http://schemas.openxmlformats.org/officeDocument/2006/relationships" xmlns:a="http://schemas.openxmlformats.org/drawingml/2006/main" r:embed="R08b6750c40f147a5"/>
           <a:srcRect xmlns:a="http://schemas.openxmlformats.org/drawingml/2006/main" l="0" t="0" r="0" b="0"/>
           <a:stretch xmlns:a="http://schemas.openxmlformats.org/drawingml/2006/main">
             <a:fillRect l="0" t="0" r="0" b="0"/>
@@ -13420,7 +13420,7 @@
           <p:cNvPr id="87" name="">
             <a:extLst xmlns:a="http://schemas.openxmlformats.org/drawingml/2006/main">
               <a:ext uri="{FF2B5EF4-FFF2-40B4-BE49-F238E27FC236}">
-                <a16:creationId xmlns:a16="http://schemas.microsoft.com/office/drawing/2014/main" id="{B405F7AE-C0C5-447F-8280-8F015BF2AB08}"/>
+                <a16:creationId xmlns:a16="http://schemas.microsoft.com/office/drawing/2014/main" id="{9FE50F3F-71C9-4FA1-8008-8A6D76BD88AF}"/>
               </a:ext>
             </a:extLst>
           </p:cNvPr>
@@ -13467,7 +13467,7 @@
                 <a:ea typeface="맑은 고딕"/>
                 <a:cs typeface="맑은 고딕"/>
               </a:rPr>
-              <a:t>사용자가 앱에서 하려는 다섯 가지 일</a:t>
+              <a:t>사용자와 주요 사용 목적</a:t>
             </a:r>
           </a:p>
         </p:txBody>
@@ -13477,7 +13477,7 @@
           <p:cNvPr id="88" name="">
             <a:extLst xmlns:a="http://schemas.openxmlformats.org/drawingml/2006/main">
               <a:ext uri="{FF2B5EF4-FFF2-40B4-BE49-F238E27FC236}">
-                <a16:creationId xmlns:a16="http://schemas.microsoft.com/office/drawing/2014/main" id="{9E6931DD-A98A-4FFF-87E3-3F7C3F9B7AEF}"/>
+                <a16:creationId xmlns:a16="http://schemas.microsoft.com/office/drawing/2014/main" id="{29ED21C8-A5D5-4F2C-8CB4-E1A31926E2CF}"/>
               </a:ext>
             </a:extLst>
           </p:cNvPr>
@@ -13534,7 +13534,7 @@
           <p:cNvPr id="89" name="">
             <a:extLst xmlns:a="http://schemas.openxmlformats.org/drawingml/2006/main">
               <a:ext uri="{FF2B5EF4-FFF2-40B4-BE49-F238E27FC236}">
-                <a16:creationId xmlns:a16="http://schemas.microsoft.com/office/drawing/2014/main" id="{FF67705F-941C-4CCA-B2A1-E4F1E2064F98}"/>
+                <a16:creationId xmlns:a16="http://schemas.microsoft.com/office/drawing/2014/main" id="{8BDF2A46-962C-445F-A8F6-5BD37D88720E}"/>
               </a:ext>
             </a:extLst>
           </p:cNvPr>
@@ -13591,7 +13591,7 @@
           <p:cNvPr id="90" name="">
             <a:extLst xmlns:a="http://schemas.openxmlformats.org/drawingml/2006/main">
               <a:ext uri="{FF2B5EF4-FFF2-40B4-BE49-F238E27FC236}">
-                <a16:creationId xmlns:a16="http://schemas.microsoft.com/office/drawing/2014/main" id="{92DEA800-DEC5-4CE9-A9CD-2E8FFFE47744}"/>
+                <a16:creationId xmlns:a16="http://schemas.microsoft.com/office/drawing/2014/main" id="{3D0E5E44-B9CE-457B-9322-5A9DAEDB29A7}"/>
               </a:ext>
             </a:extLst>
           </p:cNvPr>
@@ -13634,7 +13634,7 @@
           <p:cNvPr id="91" name="">
             <a:extLst xmlns:a="http://schemas.openxmlformats.org/drawingml/2006/main">
               <a:ext uri="{FF2B5EF4-FFF2-40B4-BE49-F238E27FC236}">
-                <a16:creationId xmlns:a16="http://schemas.microsoft.com/office/drawing/2014/main" id="{F69F2225-F2B5-4F2D-8BA3-94A32C032259}"/>
+                <a16:creationId xmlns:a16="http://schemas.microsoft.com/office/drawing/2014/main" id="{D34F7935-3C52-49DC-893E-A126825507C4}"/>
               </a:ext>
             </a:extLst>
           </p:cNvPr>
@@ -13691,7 +13691,7 @@
           <p:cNvPr id="92" name="">
             <a:extLst xmlns:a="http://schemas.openxmlformats.org/drawingml/2006/main">
               <a:ext uri="{FF2B5EF4-FFF2-40B4-BE49-F238E27FC236}">
-                <a16:creationId xmlns:a16="http://schemas.microsoft.com/office/drawing/2014/main" id="{EEB86E05-5012-4480-A389-B9AB21600D3A}"/>
+                <a16:creationId xmlns:a16="http://schemas.microsoft.com/office/drawing/2014/main" id="{465126D4-4CBE-4778-A5BE-3D0F8EC8102C}"/>
               </a:ext>
             </a:extLst>
           </p:cNvPr>
@@ -13752,7 +13752,7 @@
           <p:cNvPr id="93" name="">
             <a:extLst xmlns:a="http://schemas.openxmlformats.org/drawingml/2006/main">
               <a:ext uri="{FF2B5EF4-FFF2-40B4-BE49-F238E27FC236}">
-                <a16:creationId xmlns:a16="http://schemas.microsoft.com/office/drawing/2014/main" id="{3721646D-43C9-4A9B-AFDA-38EB34F20B57}"/>
+                <a16:creationId xmlns:a16="http://schemas.microsoft.com/office/drawing/2014/main" id="{78432A2C-3BE1-4C87-844F-3205C1E7BBD9}"/>
               </a:ext>
             </a:extLst>
           </p:cNvPr>
@@ -13837,7 +13837,7 @@
           <p:cNvPr id="95" name="">
             <a:extLst xmlns:a="http://schemas.openxmlformats.org/drawingml/2006/main">
               <a:ext uri="{FF2B5EF4-FFF2-40B4-BE49-F238E27FC236}">
-                <a16:creationId xmlns:a16="http://schemas.microsoft.com/office/drawing/2014/main" id="{97E5D1FC-EAFD-4E36-820B-E6663514E837}"/>
+                <a16:creationId xmlns:a16="http://schemas.microsoft.com/office/drawing/2014/main" id="{EF73DD45-40F7-4220-A0E2-2844A40E1C9B}"/>
               </a:ext>
             </a:extLst>
           </p:cNvPr>
@@ -13922,7 +13922,7 @@
           <p:cNvPr id="97" name="">
             <a:extLst xmlns:a="http://schemas.openxmlformats.org/drawingml/2006/main">
               <a:ext uri="{FF2B5EF4-FFF2-40B4-BE49-F238E27FC236}">
-                <a16:creationId xmlns:a16="http://schemas.microsoft.com/office/drawing/2014/main" id="{01412D3E-3977-4EE0-A77E-F03EA5A67619}"/>
+                <a16:creationId xmlns:a16="http://schemas.microsoft.com/office/drawing/2014/main" id="{6BC701CF-46AA-4C52-89CD-BB0E5D51C2D4}"/>
               </a:ext>
             </a:extLst>
           </p:cNvPr>
@@ -14007,7 +14007,7 @@
           <p:cNvPr id="99" name="">
             <a:extLst xmlns:a="http://schemas.openxmlformats.org/drawingml/2006/main">
               <a:ext uri="{FF2B5EF4-FFF2-40B4-BE49-F238E27FC236}">
-                <a16:creationId xmlns:a16="http://schemas.microsoft.com/office/drawing/2014/main" id="{BC92687A-A374-43C1-BDBA-6B169831B44D}"/>
+                <a16:creationId xmlns:a16="http://schemas.microsoft.com/office/drawing/2014/main" id="{C77C3EDF-A544-4D71-85DA-3D4DA0B6087B}"/>
               </a:ext>
             </a:extLst>
           </p:cNvPr>
@@ -14092,7 +14092,7 @@
           <p:cNvPr id="101" name="">
             <a:extLst xmlns:a="http://schemas.openxmlformats.org/drawingml/2006/main">
               <a:ext uri="{FF2B5EF4-FFF2-40B4-BE49-F238E27FC236}">
-                <a16:creationId xmlns:a16="http://schemas.microsoft.com/office/drawing/2014/main" id="{348BFF10-0A69-4DF8-96A1-DB83A895FB05}"/>
+                <a16:creationId xmlns:a16="http://schemas.microsoft.com/office/drawing/2014/main" id="{79DB7F9B-0D94-452D-9C45-344312DCD735}"/>
               </a:ext>
             </a:extLst>
           </p:cNvPr>
@@ -14427,7 +14427,7 @@
           <p:nvPr/>
         </p:nvPicPr>
         <p:blipFill>
-          <a:blip xmlns:r="http://schemas.openxmlformats.org/officeDocument/2006/relationships" xmlns:a="http://schemas.openxmlformats.org/drawingml/2006/main" r:embed="R431beee516674f0b"/>
+          <a:blip xmlns:r="http://schemas.openxmlformats.org/officeDocument/2006/relationships" xmlns:a="http://schemas.openxmlformats.org/drawingml/2006/main" r:embed="R7924ce4db9e244f3"/>
           <a:srcRect xmlns:a="http://schemas.openxmlformats.org/drawingml/2006/main" l="0" t="0" r="0" b="0"/>
           <a:stretch xmlns:a="http://schemas.openxmlformats.org/drawingml/2006/main">
             <a:fillRect l="0" t="0" r="0" b="0"/>
@@ -14518,7 +14518,7 @@
           <p:cNvPr id="87" name="">
             <a:extLst xmlns:a="http://schemas.openxmlformats.org/drawingml/2006/main">
               <a:ext uri="{FF2B5EF4-FFF2-40B4-BE49-F238E27FC236}">
-                <a16:creationId xmlns:a16="http://schemas.microsoft.com/office/drawing/2014/main" id="{98AF7119-83DF-46D5-9ACA-7DE8B6812745}"/>
+                <a16:creationId xmlns:a16="http://schemas.microsoft.com/office/drawing/2014/main" id="{B34EB077-2A1E-4205-BB08-321D287CE250}"/>
               </a:ext>
             </a:extLst>
           </p:cNvPr>
@@ -14575,7 +14575,7 @@
           <p:cNvPr id="88" name="">
             <a:extLst xmlns:a="http://schemas.openxmlformats.org/drawingml/2006/main">
               <a:ext uri="{FF2B5EF4-FFF2-40B4-BE49-F238E27FC236}">
-                <a16:creationId xmlns:a16="http://schemas.microsoft.com/office/drawing/2014/main" id="{87FA17AD-325C-4EE2-A3E1-AE449C7BBDBE}"/>
+                <a16:creationId xmlns:a16="http://schemas.microsoft.com/office/drawing/2014/main" id="{735EBCC0-6F37-48AB-BD3B-E890C654CFF8}"/>
               </a:ext>
             </a:extLst>
           </p:cNvPr>
@@ -14632,7 +14632,7 @@
           <p:cNvPr id="89" name="">
             <a:extLst xmlns:a="http://schemas.openxmlformats.org/drawingml/2006/main">
               <a:ext uri="{FF2B5EF4-FFF2-40B4-BE49-F238E27FC236}">
-                <a16:creationId xmlns:a16="http://schemas.microsoft.com/office/drawing/2014/main" id="{97E843C7-B584-47FC-B838-722466757809}"/>
+                <a16:creationId xmlns:a16="http://schemas.microsoft.com/office/drawing/2014/main" id="{5470A2A5-C3CC-4E75-AFEF-A60C39110898}"/>
               </a:ext>
             </a:extLst>
           </p:cNvPr>
@@ -15387,7 +15387,7 @@
           <p:cNvPr id="91" name="">
             <a:extLst xmlns:a="http://schemas.openxmlformats.org/drawingml/2006/main">
               <a:ext uri="{FF2B5EF4-FFF2-40B4-BE49-F238E27FC236}">
-                <a16:creationId xmlns:a16="http://schemas.microsoft.com/office/drawing/2014/main" id="{A75AF80E-232F-42E8-987D-8BFC10455E9F}"/>
+                <a16:creationId xmlns:a16="http://schemas.microsoft.com/office/drawing/2014/main" id="{951BB04B-C7B9-4DEA-A345-C87036A54F6C}"/>
               </a:ext>
             </a:extLst>
           </p:cNvPr>
@@ -15694,7 +15694,7 @@
           <p:nvPr/>
         </p:nvPicPr>
         <p:blipFill>
-          <a:blip xmlns:r="http://schemas.openxmlformats.org/officeDocument/2006/relationships" xmlns:a="http://schemas.openxmlformats.org/drawingml/2006/main" r:embed="R3074e4303d58458c"/>
+          <a:blip xmlns:r="http://schemas.openxmlformats.org/officeDocument/2006/relationships" xmlns:a="http://schemas.openxmlformats.org/drawingml/2006/main" r:embed="R1947d530c4cf4930"/>
           <a:srcRect xmlns:a="http://schemas.openxmlformats.org/drawingml/2006/main" l="0" t="0" r="0" b="0"/>
           <a:stretch xmlns:a="http://schemas.openxmlformats.org/drawingml/2006/main">
             <a:fillRect l="0" t="0" r="0" b="0"/>
@@ -15785,7 +15785,7 @@
           <p:cNvPr id="87" name="">
             <a:extLst xmlns:a="http://schemas.openxmlformats.org/drawingml/2006/main">
               <a:ext uri="{FF2B5EF4-FFF2-40B4-BE49-F238E27FC236}">
-                <a16:creationId xmlns:a16="http://schemas.microsoft.com/office/drawing/2014/main" id="{12331AFC-B65D-46CD-BFB8-D93BA576AAF4}"/>
+                <a16:creationId xmlns:a16="http://schemas.microsoft.com/office/drawing/2014/main" id="{D86192D7-02EE-4793-9464-85B92A03C7CE}"/>
               </a:ext>
             </a:extLst>
           </p:cNvPr>
@@ -15832,7 +15832,7 @@
                 <a:ea typeface="맑은 고딕"/>
                 <a:cs typeface="맑은 고딕"/>
               </a:rPr>
-              <a:t>처음에는 계획을 만들고, 이후에는 세 탭으로 사용한다</a:t>
+              <a:t>처음 이용과 일상 사용 메뉴</a:t>
             </a:r>
           </a:p>
         </p:txBody>
@@ -15842,7 +15842,7 @@
           <p:cNvPr id="88" name="">
             <a:extLst xmlns:a="http://schemas.openxmlformats.org/drawingml/2006/main">
               <a:ext uri="{FF2B5EF4-FFF2-40B4-BE49-F238E27FC236}">
-                <a16:creationId xmlns:a16="http://schemas.microsoft.com/office/drawing/2014/main" id="{89CA5E2E-0EE2-4129-B735-7DDCB1A27702}"/>
+                <a16:creationId xmlns:a16="http://schemas.microsoft.com/office/drawing/2014/main" id="{7B520D46-E900-4769-843B-CCCC028B5167}"/>
               </a:ext>
             </a:extLst>
           </p:cNvPr>
@@ -15899,7 +15899,7 @@
           <p:cNvPr id="89" name="">
             <a:extLst xmlns:a="http://schemas.openxmlformats.org/drawingml/2006/main">
               <a:ext uri="{FF2B5EF4-FFF2-40B4-BE49-F238E27FC236}">
-                <a16:creationId xmlns:a16="http://schemas.microsoft.com/office/drawing/2014/main" id="{521CC75E-E091-46CB-B68A-2E16E27C57F8}"/>
+                <a16:creationId xmlns:a16="http://schemas.microsoft.com/office/drawing/2014/main" id="{031900F6-1EA1-4A72-9EDA-89EFF5A76996}"/>
               </a:ext>
             </a:extLst>
           </p:cNvPr>
@@ -15956,7 +15956,7 @@
           <p:cNvPr id="90" name="">
             <a:extLst xmlns:a="http://schemas.openxmlformats.org/drawingml/2006/main">
               <a:ext uri="{FF2B5EF4-FFF2-40B4-BE49-F238E27FC236}">
-                <a16:creationId xmlns:a16="http://schemas.microsoft.com/office/drawing/2014/main" id="{EA2C83BB-D711-418B-A382-0D52B1D4E5C0}"/>
+                <a16:creationId xmlns:a16="http://schemas.microsoft.com/office/drawing/2014/main" id="{02E09298-9A33-420E-BC95-8F1320993CC0}"/>
               </a:ext>
             </a:extLst>
           </p:cNvPr>
@@ -16013,7 +16013,7 @@
           <p:cNvPr id="91" name="">
             <a:extLst xmlns:a="http://schemas.openxmlformats.org/drawingml/2006/main">
               <a:ext uri="{FF2B5EF4-FFF2-40B4-BE49-F238E27FC236}">
-                <a16:creationId xmlns:a16="http://schemas.microsoft.com/office/drawing/2014/main" id="{C8E84FA1-6B81-4533-ABCF-C03762A6DE66}"/>
+                <a16:creationId xmlns:a16="http://schemas.microsoft.com/office/drawing/2014/main" id="{3DFE1A53-5D07-44EC-A6C1-4D263C0B52DC}"/>
               </a:ext>
             </a:extLst>
           </p:cNvPr>
@@ -16074,7 +16074,7 @@
           <p:cNvPr id="92" name="">
             <a:extLst xmlns:a="http://schemas.openxmlformats.org/drawingml/2006/main">
               <a:ext uri="{FF2B5EF4-FFF2-40B4-BE49-F238E27FC236}">
-                <a16:creationId xmlns:a16="http://schemas.microsoft.com/office/drawing/2014/main" id="{88DEFAE5-67FF-42DB-9BA3-37F55B4BAEC6}"/>
+                <a16:creationId xmlns:a16="http://schemas.microsoft.com/office/drawing/2014/main" id="{6DA0BD47-A4D3-4110-89F0-39C817EB987C}"/>
               </a:ext>
             </a:extLst>
           </p:cNvPr>
@@ -16135,7 +16135,7 @@
           <p:cNvPr id="93" name="">
             <a:extLst xmlns:a="http://schemas.openxmlformats.org/drawingml/2006/main">
               <a:ext uri="{FF2B5EF4-FFF2-40B4-BE49-F238E27FC236}">
-                <a16:creationId xmlns:a16="http://schemas.microsoft.com/office/drawing/2014/main" id="{2040965B-0BCE-4081-BC65-1BF2302C6ACF}"/>
+                <a16:creationId xmlns:a16="http://schemas.microsoft.com/office/drawing/2014/main" id="{221D35C0-ED8C-4227-B9D3-333A0D7F8D5D}"/>
               </a:ext>
             </a:extLst>
           </p:cNvPr>
@@ -16246,7 +16246,7 @@
           <p:cNvPr id="96" name="">
             <a:extLst xmlns:a="http://schemas.openxmlformats.org/drawingml/2006/main">
               <a:ext uri="{FF2B5EF4-FFF2-40B4-BE49-F238E27FC236}">
-                <a16:creationId xmlns:a16="http://schemas.microsoft.com/office/drawing/2014/main" id="{7E4D762E-72C1-466C-9F7D-90026B8172E9}"/>
+                <a16:creationId xmlns:a16="http://schemas.microsoft.com/office/drawing/2014/main" id="{B7ED214A-6623-4336-BD8D-C2C0A84C5654}"/>
               </a:ext>
             </a:extLst>
           </p:cNvPr>
@@ -16303,7 +16303,7 @@
           <p:cNvPr id="97" name="">
             <a:extLst xmlns:a="http://schemas.openxmlformats.org/drawingml/2006/main">
               <a:ext uri="{FF2B5EF4-FFF2-40B4-BE49-F238E27FC236}">
-                <a16:creationId xmlns:a16="http://schemas.microsoft.com/office/drawing/2014/main" id="{BE0EB0E6-46ED-4F2B-B051-0260868233CC}"/>
+                <a16:creationId xmlns:a16="http://schemas.microsoft.com/office/drawing/2014/main" id="{AF368507-5419-4BB3-9190-BF41B9D416CB}"/>
               </a:ext>
             </a:extLst>
           </p:cNvPr>
@@ -16364,7 +16364,7 @@
           <p:cNvPr id="98" name="">
             <a:extLst xmlns:a="http://schemas.openxmlformats.org/drawingml/2006/main">
               <a:ext uri="{FF2B5EF4-FFF2-40B4-BE49-F238E27FC236}">
-                <a16:creationId xmlns:a16="http://schemas.microsoft.com/office/drawing/2014/main" id="{90226B46-7725-402D-B58D-CA09C73DF4BD}"/>
+                <a16:creationId xmlns:a16="http://schemas.microsoft.com/office/drawing/2014/main" id="{AE2E0E7B-0FE8-40BF-AACA-C49DE3CFCDFD}"/>
               </a:ext>
             </a:extLst>
           </p:cNvPr>
@@ -16444,7 +16444,7 @@
           <p:cNvPr id="99" name="">
             <a:extLst xmlns:a="http://schemas.openxmlformats.org/drawingml/2006/main">
               <a:ext uri="{FF2B5EF4-FFF2-40B4-BE49-F238E27FC236}">
-                <a16:creationId xmlns:a16="http://schemas.microsoft.com/office/drawing/2014/main" id="{BA7D1A37-011E-4978-9726-DFA2039466B0}"/>
+                <a16:creationId xmlns:a16="http://schemas.microsoft.com/office/drawing/2014/main" id="{FF4D2C00-C5F6-4B20-A99F-A9A002BCCF8C}"/>
               </a:ext>
             </a:extLst>
           </p:cNvPr>
@@ -16505,7 +16505,7 @@
           <p:cNvPr id="100" name="">
             <a:extLst xmlns:a="http://schemas.openxmlformats.org/drawingml/2006/main">
               <a:ext uri="{FF2B5EF4-FFF2-40B4-BE49-F238E27FC236}">
-                <a16:creationId xmlns:a16="http://schemas.microsoft.com/office/drawing/2014/main" id="{11538898-FE98-4851-A9C7-C0A437CC224D}"/>
+                <a16:creationId xmlns:a16="http://schemas.microsoft.com/office/drawing/2014/main" id="{CBC434AB-5D74-433A-914A-5DCD9145A1CE}"/>
               </a:ext>
             </a:extLst>
           </p:cNvPr>
@@ -16585,7 +16585,7 @@
           <p:cNvPr id="101" name="">
             <a:extLst xmlns:a="http://schemas.openxmlformats.org/drawingml/2006/main">
               <a:ext uri="{FF2B5EF4-FFF2-40B4-BE49-F238E27FC236}">
-                <a16:creationId xmlns:a16="http://schemas.microsoft.com/office/drawing/2014/main" id="{DC69EF7C-5D79-4F3F-898A-2102DEA030B7}"/>
+                <a16:creationId xmlns:a16="http://schemas.microsoft.com/office/drawing/2014/main" id="{B3FA3B4D-E3F4-4B6A-8B34-227D3EC5F3EF}"/>
               </a:ext>
             </a:extLst>
           </p:cNvPr>
@@ -16646,7 +16646,7 @@
           <p:cNvPr id="102" name="">
             <a:extLst xmlns:a="http://schemas.openxmlformats.org/drawingml/2006/main">
               <a:ext uri="{FF2B5EF4-FFF2-40B4-BE49-F238E27FC236}">
-                <a16:creationId xmlns:a16="http://schemas.microsoft.com/office/drawing/2014/main" id="{577D4934-61B6-4080-9ED1-FFAFD7763843}"/>
+                <a16:creationId xmlns:a16="http://schemas.microsoft.com/office/drawing/2014/main" id="{C3A31F0D-20DC-4C9F-98DD-5543B1173A4A}"/>
               </a:ext>
             </a:extLst>
           </p:cNvPr>
@@ -16726,7 +16726,7 @@
           <p:cNvPr id="103" name="">
             <a:extLst xmlns:a="http://schemas.openxmlformats.org/drawingml/2006/main">
               <a:ext uri="{FF2B5EF4-FFF2-40B4-BE49-F238E27FC236}">
-                <a16:creationId xmlns:a16="http://schemas.microsoft.com/office/drawing/2014/main" id="{2421C8E3-8F46-47E3-A0B6-18819D292BDB}"/>
+                <a16:creationId xmlns:a16="http://schemas.microsoft.com/office/drawing/2014/main" id="{362C708D-4191-4E1A-A0C4-422F1BDC43B6}"/>
               </a:ext>
             </a:extLst>
           </p:cNvPr>
@@ -16783,7 +16783,7 @@
           <p:cNvPr id="104" name="">
             <a:extLst xmlns:a="http://schemas.openxmlformats.org/drawingml/2006/main">
               <a:ext uri="{FF2B5EF4-FFF2-40B4-BE49-F238E27FC236}">
-                <a16:creationId xmlns:a16="http://schemas.microsoft.com/office/drawing/2014/main" id="{78DD21BD-8921-414F-B9E2-7B12612E1252}"/>
+                <a16:creationId xmlns:a16="http://schemas.microsoft.com/office/drawing/2014/main" id="{AD0EDDA8-4D28-4B4D-BFE6-B2E8062B21BA}"/>
               </a:ext>
             </a:extLst>
           </p:cNvPr>
@@ -16863,7 +16863,7 @@
           <p:cNvPr id="105" name="">
             <a:extLst xmlns:a="http://schemas.openxmlformats.org/drawingml/2006/main">
               <a:ext uri="{FF2B5EF4-FFF2-40B4-BE49-F238E27FC236}">
-                <a16:creationId xmlns:a16="http://schemas.microsoft.com/office/drawing/2014/main" id="{A38DAB6F-4DA7-471E-B8E1-1B955DD7BB74}"/>
+                <a16:creationId xmlns:a16="http://schemas.microsoft.com/office/drawing/2014/main" id="{03D83723-0ACE-4725-89A1-25699A64F4BA}"/>
               </a:ext>
             </a:extLst>
           </p:cNvPr>
@@ -17170,7 +17170,7 @@
           <p:nvPr/>
         </p:nvPicPr>
         <p:blipFill>
-          <a:blip xmlns:r="http://schemas.openxmlformats.org/officeDocument/2006/relationships" xmlns:a="http://schemas.openxmlformats.org/drawingml/2006/main" r:embed="R3a8b336c807a4ddb"/>
+          <a:blip xmlns:r="http://schemas.openxmlformats.org/officeDocument/2006/relationships" xmlns:a="http://schemas.openxmlformats.org/drawingml/2006/main" r:embed="R230cdeef9d314715"/>
           <a:srcRect xmlns:a="http://schemas.openxmlformats.org/drawingml/2006/main" l="0" t="0" r="0" b="0"/>
           <a:stretch xmlns:a="http://schemas.openxmlformats.org/drawingml/2006/main">
             <a:fillRect l="0" t="0" r="0" b="0"/>
@@ -17261,7 +17261,7 @@
           <p:cNvPr id="87" name="">
             <a:extLst xmlns:a="http://schemas.openxmlformats.org/drawingml/2006/main">
               <a:ext uri="{FF2B5EF4-FFF2-40B4-BE49-F238E27FC236}">
-                <a16:creationId xmlns:a16="http://schemas.microsoft.com/office/drawing/2014/main" id="{83C8FF45-BFF6-41BE-B755-0BDCA2335C03}"/>
+                <a16:creationId xmlns:a16="http://schemas.microsoft.com/office/drawing/2014/main" id="{D9897B39-756D-4067-87CA-EDF14F99999F}"/>
               </a:ext>
             </a:extLst>
           </p:cNvPr>
@@ -17318,7 +17318,7 @@
           <p:cNvPr id="88" name="">
             <a:extLst xmlns:a="http://schemas.openxmlformats.org/drawingml/2006/main">
               <a:ext uri="{FF2B5EF4-FFF2-40B4-BE49-F238E27FC236}">
-                <a16:creationId xmlns:a16="http://schemas.microsoft.com/office/drawing/2014/main" id="{D89AFEAB-82C0-4369-97E0-61A365580884}"/>
+                <a16:creationId xmlns:a16="http://schemas.microsoft.com/office/drawing/2014/main" id="{4228C868-2B8E-4C65-B708-292849813B15}"/>
               </a:ext>
             </a:extLst>
           </p:cNvPr>
@@ -17375,7 +17375,7 @@
           <p:cNvPr id="89" name="">
             <a:extLst xmlns:a="http://schemas.openxmlformats.org/drawingml/2006/main">
               <a:ext uri="{FF2B5EF4-FFF2-40B4-BE49-F238E27FC236}">
-                <a16:creationId xmlns:a16="http://schemas.microsoft.com/office/drawing/2014/main" id="{E41DCD57-389E-4CA4-85A0-72CDD38A194D}"/>
+                <a16:creationId xmlns:a16="http://schemas.microsoft.com/office/drawing/2014/main" id="{B8FB3295-BE1D-40BE-8873-E95B30580FF6}"/>
               </a:ext>
             </a:extLst>
           </p:cNvPr>
@@ -17436,7 +17436,7 @@
           <p:nvPr/>
         </p:nvPicPr>
         <p:blipFill>
-          <a:blip xmlns:r="http://schemas.openxmlformats.org/officeDocument/2006/relationships" xmlns:a="http://schemas.openxmlformats.org/drawingml/2006/main" r:embed="Rf3c9e27bba3d46ee"/>
+          <a:blip xmlns:r="http://schemas.openxmlformats.org/officeDocument/2006/relationships" xmlns:a="http://schemas.openxmlformats.org/drawingml/2006/main" r:embed="Rcece5743afd64b66"/>
           <a:stretch xmlns:a="http://schemas.openxmlformats.org/drawingml/2006/main"/>
         </p:blipFill>
         <p:spPr>
@@ -17458,7 +17458,7 @@
           <p:nvPr/>
         </p:nvPicPr>
         <p:blipFill>
-          <a:blip xmlns:r="http://schemas.openxmlformats.org/officeDocument/2006/relationships" xmlns:a="http://schemas.openxmlformats.org/drawingml/2006/main" r:embed="R13d5838b815b40b7"/>
+          <a:blip xmlns:r="http://schemas.openxmlformats.org/officeDocument/2006/relationships" xmlns:a="http://schemas.openxmlformats.org/drawingml/2006/main" r:embed="R87395353070c4de8"/>
           <a:stretch xmlns:a="http://schemas.openxmlformats.org/drawingml/2006/main"/>
         </p:blipFill>
         <p:spPr>
@@ -17476,7 +17476,7 @@
           <p:cNvPr id="92" name="">
             <a:extLst xmlns:a="http://schemas.openxmlformats.org/drawingml/2006/main">
               <a:ext uri="{FF2B5EF4-FFF2-40B4-BE49-F238E27FC236}">
-                <a16:creationId xmlns:a16="http://schemas.microsoft.com/office/drawing/2014/main" id="{15819A6D-3E01-4BD5-A0D6-EB3081BF6FFF}"/>
+                <a16:creationId xmlns:a16="http://schemas.microsoft.com/office/drawing/2014/main" id="{C8B341F9-9CDF-46F0-81E6-331ACE152420}"/>
               </a:ext>
             </a:extLst>
           </p:cNvPr>
@@ -17533,7 +17533,7 @@
           <p:cNvPr id="93" name="">
             <a:extLst xmlns:a="http://schemas.openxmlformats.org/drawingml/2006/main">
               <a:ext uri="{FF2B5EF4-FFF2-40B4-BE49-F238E27FC236}">
-                <a16:creationId xmlns:a16="http://schemas.microsoft.com/office/drawing/2014/main" id="{B2D8CD0D-4688-45C7-9429-E227CA14921B}"/>
+                <a16:creationId xmlns:a16="http://schemas.microsoft.com/office/drawing/2014/main" id="{70EB008A-80AF-403C-B109-6001DB9A7347}"/>
               </a:ext>
             </a:extLst>
           </p:cNvPr>
@@ -17590,7 +17590,7 @@
           <p:cNvPr id="94" name="">
             <a:extLst xmlns:a="http://schemas.openxmlformats.org/drawingml/2006/main">
               <a:ext uri="{FF2B5EF4-FFF2-40B4-BE49-F238E27FC236}">
-                <a16:creationId xmlns:a16="http://schemas.microsoft.com/office/drawing/2014/main" id="{F2CC42EB-3004-430B-BF00-4294D61126F8}"/>
+                <a16:creationId xmlns:a16="http://schemas.microsoft.com/office/drawing/2014/main" id="{91E29D55-30A1-4675-8D3D-E7CB3D82E0B6}"/>
               </a:ext>
             </a:extLst>
           </p:cNvPr>
@@ -17647,7 +17647,7 @@
           <p:cNvPr id="95" name="">
             <a:extLst xmlns:a="http://schemas.openxmlformats.org/drawingml/2006/main">
               <a:ext uri="{FF2B5EF4-FFF2-40B4-BE49-F238E27FC236}">
-                <a16:creationId xmlns:a16="http://schemas.microsoft.com/office/drawing/2014/main" id="{9F4DF95D-DFC1-43E5-A35A-9386CCEBBBD3}"/>
+                <a16:creationId xmlns:a16="http://schemas.microsoft.com/office/drawing/2014/main" id="{5A76A711-3CA1-485B-BE43-56E3557D446C}"/>
               </a:ext>
             </a:extLst>
           </p:cNvPr>
@@ -17750,7 +17750,7 @@
           <p:cNvPr id="96" name="">
             <a:extLst xmlns:a="http://schemas.openxmlformats.org/drawingml/2006/main">
               <a:ext uri="{FF2B5EF4-FFF2-40B4-BE49-F238E27FC236}">
-                <a16:creationId xmlns:a16="http://schemas.microsoft.com/office/drawing/2014/main" id="{E73BCB0C-10A1-4F26-8780-D18F55FCD45D}"/>
+                <a16:creationId xmlns:a16="http://schemas.microsoft.com/office/drawing/2014/main" id="{A5952607-69E1-428D-B99E-6F9961B3BFA6}"/>
               </a:ext>
             </a:extLst>
           </p:cNvPr>
@@ -17780,7 +17780,7 @@
           <p:cNvPr id="97" name="">
             <a:extLst xmlns:a="http://schemas.openxmlformats.org/drawingml/2006/main">
               <a:ext uri="{FF2B5EF4-FFF2-40B4-BE49-F238E27FC236}">
-                <a16:creationId xmlns:a16="http://schemas.microsoft.com/office/drawing/2014/main" id="{5D3E6F7B-E2B2-418A-A51D-CDA5923A187E}"/>
+                <a16:creationId xmlns:a16="http://schemas.microsoft.com/office/drawing/2014/main" id="{D4C93328-6BAF-4AAD-A97C-91B744EB6CE3}"/>
               </a:ext>
             </a:extLst>
           </p:cNvPr>
@@ -17837,7 +17837,7 @@
           <p:cNvPr id="98" name="">
             <a:extLst xmlns:a="http://schemas.openxmlformats.org/drawingml/2006/main">
               <a:ext uri="{FF2B5EF4-FFF2-40B4-BE49-F238E27FC236}">
-                <a16:creationId xmlns:a16="http://schemas.microsoft.com/office/drawing/2014/main" id="{6BB5FC06-AB76-4AD9-AAEE-9B53D6A13EB1}"/>
+                <a16:creationId xmlns:a16="http://schemas.microsoft.com/office/drawing/2014/main" id="{91BA2CC9-2CB1-4E65-BA17-6E5B39FB65DB}"/>
               </a:ext>
             </a:extLst>
           </p:cNvPr>
@@ -17940,7 +17940,7 @@
           <p:cNvPr id="99" name="">
             <a:extLst xmlns:a="http://schemas.openxmlformats.org/drawingml/2006/main">
               <a:ext uri="{FF2B5EF4-FFF2-40B4-BE49-F238E27FC236}">
-                <a16:creationId xmlns:a16="http://schemas.microsoft.com/office/drawing/2014/main" id="{33365D86-37EE-46EC-9DCB-CAA4ACDD23DE}"/>
+                <a16:creationId xmlns:a16="http://schemas.microsoft.com/office/drawing/2014/main" id="{9DE5F0AD-4953-4502-80BB-D3E7E55289C0}"/>
               </a:ext>
             </a:extLst>
           </p:cNvPr>
@@ -17997,7 +17997,7 @@
           <p:cNvPr id="100" name="">
             <a:extLst xmlns:a="http://schemas.openxmlformats.org/drawingml/2006/main">
               <a:ext uri="{FF2B5EF4-FFF2-40B4-BE49-F238E27FC236}">
-                <a16:creationId xmlns:a16="http://schemas.microsoft.com/office/drawing/2014/main" id="{C1236115-70F8-4997-9937-B7FAFD275D7B}"/>
+                <a16:creationId xmlns:a16="http://schemas.microsoft.com/office/drawing/2014/main" id="{F4D1470D-2208-41F6-A54F-ECE670AA3020}"/>
               </a:ext>
             </a:extLst>
           </p:cNvPr>
@@ -18077,7 +18077,7 @@
           <p:cNvPr id="101" name="">
             <a:extLst xmlns:a="http://schemas.openxmlformats.org/drawingml/2006/main">
               <a:ext uri="{FF2B5EF4-FFF2-40B4-BE49-F238E27FC236}">
-                <a16:creationId xmlns:a16="http://schemas.microsoft.com/office/drawing/2014/main" id="{59CFD804-4157-4019-9AFD-36F2247ADF30}"/>
+                <a16:creationId xmlns:a16="http://schemas.microsoft.com/office/drawing/2014/main" id="{268264E6-D3B2-4E72-AFFD-72A4AB210571}"/>
               </a:ext>
             </a:extLst>
           </p:cNvPr>
@@ -18384,7 +18384,7 @@
           <p:nvPr/>
         </p:nvPicPr>
         <p:blipFill>
-          <a:blip xmlns:r="http://schemas.openxmlformats.org/officeDocument/2006/relationships" xmlns:a="http://schemas.openxmlformats.org/drawingml/2006/main" r:embed="Rd6502441d78d4c9d"/>
+          <a:blip xmlns:r="http://schemas.openxmlformats.org/officeDocument/2006/relationships" xmlns:a="http://schemas.openxmlformats.org/drawingml/2006/main" r:embed="Rb6fb9bde1d5d42b7"/>
           <a:srcRect xmlns:a="http://schemas.openxmlformats.org/drawingml/2006/main" l="0" t="0" r="0" b="0"/>
           <a:stretch xmlns:a="http://schemas.openxmlformats.org/drawingml/2006/main">
             <a:fillRect l="0" t="0" r="0" b="0"/>
@@ -18475,7 +18475,7 @@
           <p:cNvPr id="87" name="">
             <a:extLst xmlns:a="http://schemas.openxmlformats.org/drawingml/2006/main">
               <a:ext uri="{FF2B5EF4-FFF2-40B4-BE49-F238E27FC236}">
-                <a16:creationId xmlns:a16="http://schemas.microsoft.com/office/drawing/2014/main" id="{5845F3B0-D961-4F0D-8D77-E7E091F54EDD}"/>
+                <a16:creationId xmlns:a16="http://schemas.microsoft.com/office/drawing/2014/main" id="{CFFE5139-0005-4B54-9D32-A7942BD529B0}"/>
               </a:ext>
             </a:extLst>
           </p:cNvPr>
@@ -18532,7 +18532,7 @@
           <p:cNvPr id="88" name="">
             <a:extLst xmlns:a="http://schemas.openxmlformats.org/drawingml/2006/main">
               <a:ext uri="{FF2B5EF4-FFF2-40B4-BE49-F238E27FC236}">
-                <a16:creationId xmlns:a16="http://schemas.microsoft.com/office/drawing/2014/main" id="{418C7EB4-38F0-4CB4-BFF3-948E864F1CA8}"/>
+                <a16:creationId xmlns:a16="http://schemas.microsoft.com/office/drawing/2014/main" id="{8E7AF5B6-BBB1-44CA-AB6D-ECF9DDCAB4BE}"/>
               </a:ext>
             </a:extLst>
           </p:cNvPr>
@@ -18589,7 +18589,7 @@
           <p:cNvPr id="89" name="">
             <a:extLst xmlns:a="http://schemas.openxmlformats.org/drawingml/2006/main">
               <a:ext uri="{FF2B5EF4-FFF2-40B4-BE49-F238E27FC236}">
-                <a16:creationId xmlns:a16="http://schemas.microsoft.com/office/drawing/2014/main" id="{7EDA3659-2884-4A99-A46C-A2D7A579B0E8}"/>
+                <a16:creationId xmlns:a16="http://schemas.microsoft.com/office/drawing/2014/main" id="{D6FBA6AC-12E2-46A7-A820-A34FEB71C1FC}"/>
               </a:ext>
             </a:extLst>
           </p:cNvPr>
@@ -18650,7 +18650,7 @@
           <p:nvPr/>
         </p:nvPicPr>
         <p:blipFill>
-          <a:blip xmlns:r="http://schemas.openxmlformats.org/officeDocument/2006/relationships" xmlns:a="http://schemas.openxmlformats.org/drawingml/2006/main" r:embed="R907f1f27248f4db8"/>
+          <a:blip xmlns:r="http://schemas.openxmlformats.org/officeDocument/2006/relationships" xmlns:a="http://schemas.openxmlformats.org/drawingml/2006/main" r:embed="Rc0fac3cae5bd4c17"/>
           <a:stretch xmlns:a="http://schemas.openxmlformats.org/drawingml/2006/main"/>
         </p:blipFill>
         <p:spPr>
@@ -18668,7 +18668,7 @@
           <p:cNvPr id="91" name="">
             <a:extLst xmlns:a="http://schemas.openxmlformats.org/drawingml/2006/main">
               <a:ext uri="{FF2B5EF4-FFF2-40B4-BE49-F238E27FC236}">
-                <a16:creationId xmlns:a16="http://schemas.microsoft.com/office/drawing/2014/main" id="{9D27DB3F-1D59-4FAE-B26D-A8A7FB0AF756}"/>
+                <a16:creationId xmlns:a16="http://schemas.microsoft.com/office/drawing/2014/main" id="{514FFA30-E053-4411-8E41-8B7423ACBF07}"/>
               </a:ext>
             </a:extLst>
           </p:cNvPr>
@@ -18725,7 +18725,7 @@
           <p:cNvPr id="92" name="">
             <a:extLst xmlns:a="http://schemas.openxmlformats.org/drawingml/2006/main">
               <a:ext uri="{FF2B5EF4-FFF2-40B4-BE49-F238E27FC236}">
-                <a16:creationId xmlns:a16="http://schemas.microsoft.com/office/drawing/2014/main" id="{8822FB7D-02F4-4DC0-9CBD-F301C5E0CCCD}"/>
+                <a16:creationId xmlns:a16="http://schemas.microsoft.com/office/drawing/2014/main" id="{B123D787-AAF3-4C09-A8F7-E730B556DED8}"/>
               </a:ext>
             </a:extLst>
           </p:cNvPr>
@@ -18782,7 +18782,7 @@
           <p:cNvPr id="93" name="">
             <a:extLst xmlns:a="http://schemas.openxmlformats.org/drawingml/2006/main">
               <a:ext uri="{FF2B5EF4-FFF2-40B4-BE49-F238E27FC236}">
-                <a16:creationId xmlns:a16="http://schemas.microsoft.com/office/drawing/2014/main" id="{B48E8064-E4C2-45BD-AE05-D4423B381787}"/>
+                <a16:creationId xmlns:a16="http://schemas.microsoft.com/office/drawing/2014/main" id="{E2E8FDAF-E89A-4503-83DB-41FB92656101}"/>
               </a:ext>
             </a:extLst>
           </p:cNvPr>
@@ -18885,7 +18885,7 @@
           <p:cNvPr id="94" name="">
             <a:extLst xmlns:a="http://schemas.openxmlformats.org/drawingml/2006/main">
               <a:ext uri="{FF2B5EF4-FFF2-40B4-BE49-F238E27FC236}">
-                <a16:creationId xmlns:a16="http://schemas.microsoft.com/office/drawing/2014/main" id="{1897E698-E06A-481B-A7A5-68EC7DC43E4D}"/>
+                <a16:creationId xmlns:a16="http://schemas.microsoft.com/office/drawing/2014/main" id="{7731F030-0F97-4492-BE7C-B2053A317FFB}"/>
               </a:ext>
             </a:extLst>
           </p:cNvPr>
@@ -18915,7 +18915,7 @@
           <p:cNvPr id="95" name="">
             <a:extLst xmlns:a="http://schemas.openxmlformats.org/drawingml/2006/main">
               <a:ext uri="{FF2B5EF4-FFF2-40B4-BE49-F238E27FC236}">
-                <a16:creationId xmlns:a16="http://schemas.microsoft.com/office/drawing/2014/main" id="{B364F532-B672-452E-B36A-FBEFAEBFC6A7}"/>
+                <a16:creationId xmlns:a16="http://schemas.microsoft.com/office/drawing/2014/main" id="{800FD4A6-B91B-4BAF-B593-9D26E7A0655C}"/>
               </a:ext>
             </a:extLst>
           </p:cNvPr>
@@ -18972,7 +18972,7 @@
           <p:cNvPr id="96" name="">
             <a:extLst xmlns:a="http://schemas.openxmlformats.org/drawingml/2006/main">
               <a:ext uri="{FF2B5EF4-FFF2-40B4-BE49-F238E27FC236}">
-                <a16:creationId xmlns:a16="http://schemas.microsoft.com/office/drawing/2014/main" id="{50A4ABAD-B9D3-4E64-8AA3-5371EE8FB391}"/>
+                <a16:creationId xmlns:a16="http://schemas.microsoft.com/office/drawing/2014/main" id="{8720486B-9516-402B-9512-E58EFFADE23C}"/>
               </a:ext>
             </a:extLst>
           </p:cNvPr>
@@ -19075,7 +19075,7 @@
           <p:cNvPr id="97" name="">
             <a:extLst xmlns:a="http://schemas.openxmlformats.org/drawingml/2006/main">
               <a:ext uri="{FF2B5EF4-FFF2-40B4-BE49-F238E27FC236}">
-                <a16:creationId xmlns:a16="http://schemas.microsoft.com/office/drawing/2014/main" id="{6CAE5004-D7AC-4E5D-AEF8-BD2FFFE6ABEE}"/>
+                <a16:creationId xmlns:a16="http://schemas.microsoft.com/office/drawing/2014/main" id="{D3B82A14-2D35-4A38-A1CD-A9F2DC776DB2}"/>
               </a:ext>
             </a:extLst>
           </p:cNvPr>
@@ -19132,7 +19132,7 @@
           <p:cNvPr id="98" name="">
             <a:extLst xmlns:a="http://schemas.openxmlformats.org/drawingml/2006/main">
               <a:ext uri="{FF2B5EF4-FFF2-40B4-BE49-F238E27FC236}">
-                <a16:creationId xmlns:a16="http://schemas.microsoft.com/office/drawing/2014/main" id="{F917642E-AD7F-4E7C-90E3-33F40A8DDAA5}"/>
+                <a16:creationId xmlns:a16="http://schemas.microsoft.com/office/drawing/2014/main" id="{34711BBC-F8BA-4A5B-8FBD-FBD404C9547C}"/>
               </a:ext>
             </a:extLst>
           </p:cNvPr>
@@ -19212,7 +19212,7 @@
           <p:cNvPr id="99" name="">
             <a:extLst xmlns:a="http://schemas.openxmlformats.org/drawingml/2006/main">
               <a:ext uri="{FF2B5EF4-FFF2-40B4-BE49-F238E27FC236}">
-                <a16:creationId xmlns:a16="http://schemas.microsoft.com/office/drawing/2014/main" id="{4B1F6B30-7336-4802-87DA-3AD5A5CF1E6C}"/>
+                <a16:creationId xmlns:a16="http://schemas.microsoft.com/office/drawing/2014/main" id="{17C3CA09-F839-4175-AFD4-3F1D9E7422D0}"/>
               </a:ext>
             </a:extLst>
           </p:cNvPr>
@@ -19519,7 +19519,7 @@
           <p:nvPr/>
         </p:nvPicPr>
         <p:blipFill>
-          <a:blip xmlns:r="http://schemas.openxmlformats.org/officeDocument/2006/relationships" xmlns:a="http://schemas.openxmlformats.org/drawingml/2006/main" r:embed="R4573a7de6a0a4d26"/>
+          <a:blip xmlns:r="http://schemas.openxmlformats.org/officeDocument/2006/relationships" xmlns:a="http://schemas.openxmlformats.org/drawingml/2006/main" r:embed="R9142c327ddaf409f"/>
           <a:srcRect xmlns:a="http://schemas.openxmlformats.org/drawingml/2006/main" l="0" t="0" r="0" b="0"/>
           <a:stretch xmlns:a="http://schemas.openxmlformats.org/drawingml/2006/main">
             <a:fillRect l="0" t="0" r="0" b="0"/>
@@ -19610,7 +19610,7 @@
           <p:cNvPr id="87" name="">
             <a:extLst xmlns:a="http://schemas.openxmlformats.org/drawingml/2006/main">
               <a:ext uri="{FF2B5EF4-FFF2-40B4-BE49-F238E27FC236}">
-                <a16:creationId xmlns:a16="http://schemas.microsoft.com/office/drawing/2014/main" id="{ADDA0FBE-7A15-4243-B61B-96FEC9C6F2F4}"/>
+                <a16:creationId xmlns:a16="http://schemas.microsoft.com/office/drawing/2014/main" id="{4EC6B063-9A88-44E0-9FF3-09B7ABEEC42F}"/>
               </a:ext>
             </a:extLst>
           </p:cNvPr>
@@ -19667,7 +19667,7 @@
           <p:cNvPr id="88" name="">
             <a:extLst xmlns:a="http://schemas.openxmlformats.org/drawingml/2006/main">
               <a:ext uri="{FF2B5EF4-FFF2-40B4-BE49-F238E27FC236}">
-                <a16:creationId xmlns:a16="http://schemas.microsoft.com/office/drawing/2014/main" id="{957EB0EC-445C-49A3-8CAC-1C99F61D89F4}"/>
+                <a16:creationId xmlns:a16="http://schemas.microsoft.com/office/drawing/2014/main" id="{5E3D4E5C-70D1-4718-8244-7FC83D0F8529}"/>
               </a:ext>
             </a:extLst>
           </p:cNvPr>
@@ -19724,7 +19724,7 @@
           <p:cNvPr id="89" name="">
             <a:extLst xmlns:a="http://schemas.openxmlformats.org/drawingml/2006/main">
               <a:ext uri="{FF2B5EF4-FFF2-40B4-BE49-F238E27FC236}">
-                <a16:creationId xmlns:a16="http://schemas.microsoft.com/office/drawing/2014/main" id="{E6B07C55-2BD0-4693-A526-C11668439FCC}"/>
+                <a16:creationId xmlns:a16="http://schemas.microsoft.com/office/drawing/2014/main" id="{A7E6031E-9598-4DC1-BFD8-20273EF04C44}"/>
               </a:ext>
             </a:extLst>
           </p:cNvPr>
@@ -19785,7 +19785,7 @@
           <p:nvPr/>
         </p:nvPicPr>
         <p:blipFill>
-          <a:blip xmlns:r="http://schemas.openxmlformats.org/officeDocument/2006/relationships" xmlns:a="http://schemas.openxmlformats.org/drawingml/2006/main" r:embed="Rd58c190d7fe148ff"/>
+          <a:blip xmlns:r="http://schemas.openxmlformats.org/officeDocument/2006/relationships" xmlns:a="http://schemas.openxmlformats.org/drawingml/2006/main" r:embed="R43acfa845076408d"/>
           <a:stretch xmlns:a="http://schemas.openxmlformats.org/drawingml/2006/main"/>
         </p:blipFill>
         <p:spPr>
@@ -19807,7 +19807,7 @@
           <p:nvPr/>
         </p:nvPicPr>
         <p:blipFill>
-          <a:blip xmlns:r="http://schemas.openxmlformats.org/officeDocument/2006/relationships" xmlns:a="http://schemas.openxmlformats.org/drawingml/2006/main" r:embed="Rc3426ff7e36248d5"/>
+          <a:blip xmlns:r="http://schemas.openxmlformats.org/officeDocument/2006/relationships" xmlns:a="http://schemas.openxmlformats.org/drawingml/2006/main" r:embed="Rdb5b0b0e6cd34380"/>
           <a:stretch xmlns:a="http://schemas.openxmlformats.org/drawingml/2006/main"/>
         </p:blipFill>
         <p:spPr>
@@ -19825,7 +19825,7 @@
           <p:cNvPr id="92" name="">
             <a:extLst xmlns:a="http://schemas.openxmlformats.org/drawingml/2006/main">
               <a:ext uri="{FF2B5EF4-FFF2-40B4-BE49-F238E27FC236}">
-                <a16:creationId xmlns:a16="http://schemas.microsoft.com/office/drawing/2014/main" id="{F18C15C7-4504-4864-A182-AE98899935A4}"/>
+                <a16:creationId xmlns:a16="http://schemas.microsoft.com/office/drawing/2014/main" id="{C419BED2-DA41-45A1-B88E-5909A11918C1}"/>
               </a:ext>
             </a:extLst>
           </p:cNvPr>
@@ -19882,7 +19882,7 @@
           <p:cNvPr id="93" name="">
             <a:extLst xmlns:a="http://schemas.openxmlformats.org/drawingml/2006/main">
               <a:ext uri="{FF2B5EF4-FFF2-40B4-BE49-F238E27FC236}">
-                <a16:creationId xmlns:a16="http://schemas.microsoft.com/office/drawing/2014/main" id="{2952CFC5-1730-45D5-AF9A-6D7C9EAC7EA2}"/>
+                <a16:creationId xmlns:a16="http://schemas.microsoft.com/office/drawing/2014/main" id="{3F1A9BF7-27F1-4B2A-81C7-34C9904B5012}"/>
               </a:ext>
             </a:extLst>
           </p:cNvPr>
@@ -19939,7 +19939,7 @@
           <p:cNvPr id="94" name="">
             <a:extLst xmlns:a="http://schemas.openxmlformats.org/drawingml/2006/main">
               <a:ext uri="{FF2B5EF4-FFF2-40B4-BE49-F238E27FC236}">
-                <a16:creationId xmlns:a16="http://schemas.microsoft.com/office/drawing/2014/main" id="{693F9BC8-7693-4CC1-94E8-5B76C403CD62}"/>
+                <a16:creationId xmlns:a16="http://schemas.microsoft.com/office/drawing/2014/main" id="{12F0D26C-27B7-48E8-903A-99CB30ABC581}"/>
               </a:ext>
             </a:extLst>
           </p:cNvPr>
@@ -19996,7 +19996,7 @@
           <p:cNvPr id="95" name="">
             <a:extLst xmlns:a="http://schemas.openxmlformats.org/drawingml/2006/main">
               <a:ext uri="{FF2B5EF4-FFF2-40B4-BE49-F238E27FC236}">
-                <a16:creationId xmlns:a16="http://schemas.microsoft.com/office/drawing/2014/main" id="{AC860B32-C9A5-46CB-94AF-087010AEA71A}"/>
+                <a16:creationId xmlns:a16="http://schemas.microsoft.com/office/drawing/2014/main" id="{7616189A-7106-4001-93CE-BDFB8B5F2DEF}"/>
               </a:ext>
             </a:extLst>
           </p:cNvPr>
@@ -20099,7 +20099,7 @@
           <p:cNvPr id="96" name="">
             <a:extLst xmlns:a="http://schemas.openxmlformats.org/drawingml/2006/main">
               <a:ext uri="{FF2B5EF4-FFF2-40B4-BE49-F238E27FC236}">
-                <a16:creationId xmlns:a16="http://schemas.microsoft.com/office/drawing/2014/main" id="{DC464E0D-7FC4-4C4D-A62B-A9ACD505D680}"/>
+                <a16:creationId xmlns:a16="http://schemas.microsoft.com/office/drawing/2014/main" id="{F4975B50-ADA0-40AA-BB56-024D0AEA786D}"/>
               </a:ext>
             </a:extLst>
           </p:cNvPr>
@@ -20129,7 +20129,7 @@
           <p:cNvPr id="97" name="">
             <a:extLst xmlns:a="http://schemas.openxmlformats.org/drawingml/2006/main">
               <a:ext uri="{FF2B5EF4-FFF2-40B4-BE49-F238E27FC236}">
-                <a16:creationId xmlns:a16="http://schemas.microsoft.com/office/drawing/2014/main" id="{E0C2EE99-E863-4FE4-AD3E-DB3EBE4287E6}"/>
+                <a16:creationId xmlns:a16="http://schemas.microsoft.com/office/drawing/2014/main" id="{7DC74E4C-BBF5-47A8-9F82-15BB8E6AC759}"/>
               </a:ext>
             </a:extLst>
           </p:cNvPr>
@@ -20186,7 +20186,7 @@
           <p:cNvPr id="98" name="">
             <a:extLst xmlns:a="http://schemas.openxmlformats.org/drawingml/2006/main">
               <a:ext uri="{FF2B5EF4-FFF2-40B4-BE49-F238E27FC236}">
-                <a16:creationId xmlns:a16="http://schemas.microsoft.com/office/drawing/2014/main" id="{1053C930-60DD-4666-B967-B939BDAA038D}"/>
+                <a16:creationId xmlns:a16="http://schemas.microsoft.com/office/drawing/2014/main" id="{378D2463-48A9-4675-AC72-0F9661AE4460}"/>
               </a:ext>
             </a:extLst>
           </p:cNvPr>
@@ -20289,7 +20289,7 @@
           <p:cNvPr id="99" name="">
             <a:extLst xmlns:a="http://schemas.openxmlformats.org/drawingml/2006/main">
               <a:ext uri="{FF2B5EF4-FFF2-40B4-BE49-F238E27FC236}">
-                <a16:creationId xmlns:a16="http://schemas.microsoft.com/office/drawing/2014/main" id="{0ABADF9C-370E-4D4D-AB30-C9DAD91408A2}"/>
+                <a16:creationId xmlns:a16="http://schemas.microsoft.com/office/drawing/2014/main" id="{0EE112C1-D166-455C-8C50-1D3A42A12182}"/>
               </a:ext>
             </a:extLst>
           </p:cNvPr>
@@ -20346,7 +20346,7 @@
           <p:cNvPr id="100" name="">
             <a:extLst xmlns:a="http://schemas.openxmlformats.org/drawingml/2006/main">
               <a:ext uri="{FF2B5EF4-FFF2-40B4-BE49-F238E27FC236}">
-                <a16:creationId xmlns:a16="http://schemas.microsoft.com/office/drawing/2014/main" id="{19F89753-ADA3-4756-A7CE-6C682A97D514}"/>
+                <a16:creationId xmlns:a16="http://schemas.microsoft.com/office/drawing/2014/main" id="{7F6FB6D6-B176-471B-8F56-4839A693A36B}"/>
               </a:ext>
             </a:extLst>
           </p:cNvPr>
@@ -20449,7 +20449,7 @@
           <p:cNvPr id="101" name="">
             <a:extLst xmlns:a="http://schemas.openxmlformats.org/drawingml/2006/main">
               <a:ext uri="{FF2B5EF4-FFF2-40B4-BE49-F238E27FC236}">
-                <a16:creationId xmlns:a16="http://schemas.microsoft.com/office/drawing/2014/main" id="{3EF82704-CEC0-401E-A0EB-BE332006C372}"/>
+                <a16:creationId xmlns:a16="http://schemas.microsoft.com/office/drawing/2014/main" id="{1AC48CC2-5C3A-4F82-BCB3-51F22A289A72}"/>
               </a:ext>
             </a:extLst>
           </p:cNvPr>
@@ -20756,7 +20756,7 @@
           <p:nvPr/>
         </p:nvPicPr>
         <p:blipFill>
-          <a:blip xmlns:r="http://schemas.openxmlformats.org/officeDocument/2006/relationships" xmlns:a="http://schemas.openxmlformats.org/drawingml/2006/main" r:embed="R3711d11af4f24097"/>
+          <a:blip xmlns:r="http://schemas.openxmlformats.org/officeDocument/2006/relationships" xmlns:a="http://schemas.openxmlformats.org/drawingml/2006/main" r:embed="Re26faf5210be4831"/>
           <a:srcRect xmlns:a="http://schemas.openxmlformats.org/drawingml/2006/main" l="0" t="0" r="0" b="0"/>
           <a:stretch xmlns:a="http://schemas.openxmlformats.org/drawingml/2006/main">
             <a:fillRect l="0" t="0" r="0" b="0"/>
@@ -20847,7 +20847,7 @@
           <p:cNvPr id="87" name="">
             <a:extLst xmlns:a="http://schemas.openxmlformats.org/drawingml/2006/main">
               <a:ext uri="{FF2B5EF4-FFF2-40B4-BE49-F238E27FC236}">
-                <a16:creationId xmlns:a16="http://schemas.microsoft.com/office/drawing/2014/main" id="{4041797E-6D08-4108-B90C-A363BE5C3B29}"/>
+                <a16:creationId xmlns:a16="http://schemas.microsoft.com/office/drawing/2014/main" id="{DA7099BE-5337-4C25-B6DA-E30B4FB4078A}"/>
               </a:ext>
             </a:extLst>
           </p:cNvPr>
@@ -20904,7 +20904,7 @@
           <p:cNvPr id="88" name="">
             <a:extLst xmlns:a="http://schemas.openxmlformats.org/drawingml/2006/main">
               <a:ext uri="{FF2B5EF4-FFF2-40B4-BE49-F238E27FC236}">
-                <a16:creationId xmlns:a16="http://schemas.microsoft.com/office/drawing/2014/main" id="{3D499302-6FE1-4514-BD09-AFEC2FFC1BD4}"/>
+                <a16:creationId xmlns:a16="http://schemas.microsoft.com/office/drawing/2014/main" id="{952162EC-1F53-4DD9-BA29-C7F9DAF3A8C6}"/>
               </a:ext>
             </a:extLst>
           </p:cNvPr>
@@ -20961,7 +20961,7 @@
           <p:cNvPr id="89" name="">
             <a:extLst xmlns:a="http://schemas.openxmlformats.org/drawingml/2006/main">
               <a:ext uri="{FF2B5EF4-FFF2-40B4-BE49-F238E27FC236}">
-                <a16:creationId xmlns:a16="http://schemas.microsoft.com/office/drawing/2014/main" id="{BCAD3FD3-2935-469F-B631-AEF96B2FCCF3}"/>
+                <a16:creationId xmlns:a16="http://schemas.microsoft.com/office/drawing/2014/main" id="{74D95D1B-EC2B-45F6-8954-9952619BC26E}"/>
               </a:ext>
             </a:extLst>
           </p:cNvPr>
@@ -21022,7 +21022,7 @@
           <p:nvPr/>
         </p:nvPicPr>
         <p:blipFill>
-          <a:blip xmlns:r="http://schemas.openxmlformats.org/officeDocument/2006/relationships" xmlns:a="http://schemas.openxmlformats.org/drawingml/2006/main" r:embed="Rcc859d390b284bec"/>
+          <a:blip xmlns:r="http://schemas.openxmlformats.org/officeDocument/2006/relationships" xmlns:a="http://schemas.openxmlformats.org/drawingml/2006/main" r:embed="R6069748e1518435e"/>
           <a:stretch xmlns:a="http://schemas.openxmlformats.org/drawingml/2006/main"/>
         </p:blipFill>
         <p:spPr>
@@ -21044,7 +21044,7 @@
           <p:nvPr/>
         </p:nvPicPr>
         <p:blipFill>
-          <a:blip xmlns:r="http://schemas.openxmlformats.org/officeDocument/2006/relationships" xmlns:a="http://schemas.openxmlformats.org/drawingml/2006/main" r:embed="R9dba6c707f834863"/>
+          <a:blip xmlns:r="http://schemas.openxmlformats.org/officeDocument/2006/relationships" xmlns:a="http://schemas.openxmlformats.org/drawingml/2006/main" r:embed="Re193ffe4db2947f6"/>
           <a:stretch xmlns:a="http://schemas.openxmlformats.org/drawingml/2006/main"/>
         </p:blipFill>
         <p:spPr>
@@ -21062,7 +21062,7 @@
           <p:cNvPr id="92" name="">
             <a:extLst xmlns:a="http://schemas.openxmlformats.org/drawingml/2006/main">
               <a:ext uri="{FF2B5EF4-FFF2-40B4-BE49-F238E27FC236}">
-                <a16:creationId xmlns:a16="http://schemas.microsoft.com/office/drawing/2014/main" id="{A6F60413-20B6-4BC8-A71D-C5592000E706}"/>
+                <a16:creationId xmlns:a16="http://schemas.microsoft.com/office/drawing/2014/main" id="{55157941-0618-4CA9-8C61-B0B4CB1F553C}"/>
               </a:ext>
             </a:extLst>
           </p:cNvPr>
@@ -21119,7 +21119,7 @@
           <p:cNvPr id="93" name="">
             <a:extLst xmlns:a="http://schemas.openxmlformats.org/drawingml/2006/main">
               <a:ext uri="{FF2B5EF4-FFF2-40B4-BE49-F238E27FC236}">
-                <a16:creationId xmlns:a16="http://schemas.microsoft.com/office/drawing/2014/main" id="{266BF792-0592-4156-B008-A849C0E3B0D8}"/>
+                <a16:creationId xmlns:a16="http://schemas.microsoft.com/office/drawing/2014/main" id="{D11C1C02-F250-4784-89A0-2CB9394D25E4}"/>
               </a:ext>
             </a:extLst>
           </p:cNvPr>
@@ -21176,7 +21176,7 @@
           <p:cNvPr id="94" name="">
             <a:extLst xmlns:a="http://schemas.openxmlformats.org/drawingml/2006/main">
               <a:ext uri="{FF2B5EF4-FFF2-40B4-BE49-F238E27FC236}">
-                <a16:creationId xmlns:a16="http://schemas.microsoft.com/office/drawing/2014/main" id="{1C62B1F5-6346-4750-A034-AA45CEF8364E}"/>
+                <a16:creationId xmlns:a16="http://schemas.microsoft.com/office/drawing/2014/main" id="{6C4EE3A2-EAD3-437C-BF1E-6B72214B8C0F}"/>
               </a:ext>
             </a:extLst>
           </p:cNvPr>
@@ -21233,7 +21233,7 @@
           <p:cNvPr id="95" name="">
             <a:extLst xmlns:a="http://schemas.openxmlformats.org/drawingml/2006/main">
               <a:ext uri="{FF2B5EF4-FFF2-40B4-BE49-F238E27FC236}">
-                <a16:creationId xmlns:a16="http://schemas.microsoft.com/office/drawing/2014/main" id="{BEB4516E-369D-4042-A256-992EADD7D473}"/>
+                <a16:creationId xmlns:a16="http://schemas.microsoft.com/office/drawing/2014/main" id="{23B17F40-8739-4580-87DC-3B23B2656590}"/>
               </a:ext>
             </a:extLst>
           </p:cNvPr>
@@ -21336,7 +21336,7 @@
           <p:cNvPr id="96" name="">
             <a:extLst xmlns:a="http://schemas.openxmlformats.org/drawingml/2006/main">
               <a:ext uri="{FF2B5EF4-FFF2-40B4-BE49-F238E27FC236}">
-                <a16:creationId xmlns:a16="http://schemas.microsoft.com/office/drawing/2014/main" id="{00460CD5-C172-4015-B60F-84CA6B498F63}"/>
+                <a16:creationId xmlns:a16="http://schemas.microsoft.com/office/drawing/2014/main" id="{2EB1749F-4878-4077-8473-324491FF0470}"/>
               </a:ext>
             </a:extLst>
           </p:cNvPr>
@@ -21366,7 +21366,7 @@
           <p:cNvPr id="97" name="">
             <a:extLst xmlns:a="http://schemas.openxmlformats.org/drawingml/2006/main">
               <a:ext uri="{FF2B5EF4-FFF2-40B4-BE49-F238E27FC236}">
-                <a16:creationId xmlns:a16="http://schemas.microsoft.com/office/drawing/2014/main" id="{6930FE05-A126-44B7-91A4-F369D4AC14C5}"/>
+                <a16:creationId xmlns:a16="http://schemas.microsoft.com/office/drawing/2014/main" id="{83090CA1-CC91-4C64-AC82-72662545975D}"/>
               </a:ext>
             </a:extLst>
           </p:cNvPr>
@@ -21423,7 +21423,7 @@
           <p:cNvPr id="98" name="">
             <a:extLst xmlns:a="http://schemas.openxmlformats.org/drawingml/2006/main">
               <a:ext uri="{FF2B5EF4-FFF2-40B4-BE49-F238E27FC236}">
-                <a16:creationId xmlns:a16="http://schemas.microsoft.com/office/drawing/2014/main" id="{95D8BEE5-530B-41C6-BA9F-2EC6E5416524}"/>
+                <a16:creationId xmlns:a16="http://schemas.microsoft.com/office/drawing/2014/main" id="{3603229C-3D00-4431-860A-20D73323F4EF}"/>
               </a:ext>
             </a:extLst>
           </p:cNvPr>
@@ -21526,7 +21526,7 @@
           <p:cNvPr id="99" name="">
             <a:extLst xmlns:a="http://schemas.openxmlformats.org/drawingml/2006/main">
               <a:ext uri="{FF2B5EF4-FFF2-40B4-BE49-F238E27FC236}">
-                <a16:creationId xmlns:a16="http://schemas.microsoft.com/office/drawing/2014/main" id="{9B1624AC-2BAB-482D-80AC-E14BD1C9FD9B}"/>
+                <a16:creationId xmlns:a16="http://schemas.microsoft.com/office/drawing/2014/main" id="{99DB06F1-5693-42DB-86C6-05D4C9CCFDF9}"/>
               </a:ext>
             </a:extLst>
           </p:cNvPr>
@@ -21583,7 +21583,7 @@
           <p:cNvPr id="100" name="">
             <a:extLst xmlns:a="http://schemas.openxmlformats.org/drawingml/2006/main">
               <a:ext uri="{FF2B5EF4-FFF2-40B4-BE49-F238E27FC236}">
-                <a16:creationId xmlns:a16="http://schemas.microsoft.com/office/drawing/2014/main" id="{39E981E3-2F56-42A0-8B92-CC3AEE8D8878}"/>
+                <a16:creationId xmlns:a16="http://schemas.microsoft.com/office/drawing/2014/main" id="{AC558D98-1D46-4496-8A05-E153981429A0}"/>
               </a:ext>
             </a:extLst>
           </p:cNvPr>
@@ -21686,7 +21686,7 @@
           <p:cNvPr id="101" name="">
             <a:extLst xmlns:a="http://schemas.openxmlformats.org/drawingml/2006/main">
               <a:ext uri="{FF2B5EF4-FFF2-40B4-BE49-F238E27FC236}">
-                <a16:creationId xmlns:a16="http://schemas.microsoft.com/office/drawing/2014/main" id="{CB079A20-DDF5-4277-8793-A8EAAEB870C8}"/>
+                <a16:creationId xmlns:a16="http://schemas.microsoft.com/office/drawing/2014/main" id="{D6230C07-B593-400E-A196-2A882CBC2B18}"/>
               </a:ext>
             </a:extLst>
           </p:cNvPr>

</xml_diff>